<commit_message>
Welle 3: VA04 kuratiertes Deck + 2 Schaubilder (Web/Admin/Workbook)
Co-Authored-By: Claude Fable 5 <noreply@anthropic.com>
</commit_message>
<xml_diff>
--- a/protected-downloads/praesentation/VA04.pptx
+++ b/protected-downloads/praesentation/VA04.pptx
@@ -12,6 +12,15 @@
     <p:sldId id="260" r:id="rId12"/>
     <p:sldId id="261" r:id="rId13"/>
     <p:sldId id="262" r:id="rId14"/>
+    <p:sldId id="263" r:id="rId15"/>
+    <p:sldId id="264" r:id="rId16"/>
+    <p:sldId id="265" r:id="rId17"/>
+    <p:sldId id="266" r:id="rId18"/>
+    <p:sldId id="267" r:id="rId19"/>
+    <p:sldId id="268" r:id="rId20"/>
+    <p:sldId id="269" r:id="rId21"/>
+    <p:sldId id="270" r:id="rId22"/>
+    <p:sldId id="271" r:id="rId23"/>
   </p:sldIdLst>
   <p:sldSz cx="12188952" cy="6858000" type="screen4x3"/>
   <p:notesSz cx="6858000" cy="9144000"/>
@@ -578,7 +587,7 @@
           <a:lstStyle/>
           <a:p>
             <a:r>
-              <a:t>Siehe Trainerhandbuch (Sektion 3) für Moderationshinweise, Timing und erwartete Teilnehmerreaktionen.</a:t>
+              <a:t>Einstieg „die Übersicht": vor einzelnen Wiedervorlagen braucht die Assistenz den Portfolio-Blick (agree-Auswertung aller § 18-pflichtigen Engagements mit offenen Fristen). Aufruf hausindividuell im Transfer klären.</a:t>
             </a:r>
           </a:p>
         </p:txBody>
@@ -648,37 +657,7 @@
           <a:lstStyle/>
           <a:p>
             <a:r>
-              <a:t>AB-1 Musterlösung (Trainer-Version)</a:t>
-            </a:r>
-          </a:p>
-          <a:p>
-            <a:r>
-              <a:t>Priorität 1: Handel Musterregion – überfällige § 18-Offenlegung (Risiko, regulatorisch, höchste Dringlichkeit, Marktfolge informieren). Priorität 2: Pflege Musterregion – Bürgschaftsnachweis, Frist in 3 Wochen (Sicherheit gefährdet). Priorität 3: Logistik Musterregion – Zinsbindung in 6 Wochen (WV setzen, zugleich Vertriebsanlass für Prolongation). Priorität 4: Technik Musterregion – Adresse bereinigen (wichtig, aber kein unmittelbares Risiko/Frist).</a:t>
-            </a:r>
-          </a:p>
-          <a:p>
-            <a:r>
-              <a:t>Kernbefund: Risiko- und fristgetriebene Befunde gehen vor Komfort-Themen. Die auslaufende Zinsbindung ist zugleich ein Vertriebsanlass – Fristensteuerung und Vertrieb hängen zusammen (Brücke zu VA09).</a:t>
-            </a:r>
-          </a:p>
-          <a:p>
-            <a:r>
-              <a:t>Trainer-Hinweis: Lernkern ist die Priorisierung nach Risiko/Frist, nicht nach Reihenfolge des Auftretens. Die Zinsbindung als Vertriebsanlass herausarbeiten – das verbindet K-A02 mit K-A05.</a:t>
-            </a:r>
-          </a:p>
-          <a:p>
-            <a:r>
-              <a:t>AB-3 Musterlösung (Trainer-Version)</a:t>
-            </a:r>
-          </a:p>
-          <a:p>
-            <a:r>
-              <a:t>Eine Adressänderung ist nur dann ein belastbarer Beleg, wenn sie nachvollziehbar dokumentiert ist. Rechtssicher belegt wird sie durch: (a) eine schriftliche Mitteilung des Kunden (E-Mail oder Brief genügt – als Dokument in agree ablegen), (b) einen aktuellen HR-Auszug, sofern vorhanden, oder (c) eine telefonische Rückfrage beim Geschäftsführer mit anschließender Dokumentation im System (Wer, Wann, Was). Eine rein mündliche Auskunft ohne Systemnotiz ist kein Beleg.</a:t>
-            </a:r>
-          </a:p>
-          <a:p>
-            <a:r>
-              <a:t>Trainer-Hinweis: Die Frage „rechtssicher" verunsichert Teilnehmer regelmäßig. Klarmachen: Es geht nicht um juristische Perfektion, sondern um Nachvollziehbarkeit – jede Stammdatenänderung braucht einen belegbaren Auslöser, der im System auffindbar ist.</a:t>
+              <a:t>Priorisierungsregel explizit machen: ein § 18-Befund schlägt eine zeitlich nähere, aber weniger kritische Frist. Zinsbindungsende zugleich als Vertriebsanlass markieren.</a:t>
             </a:r>
           </a:p>
         </p:txBody>
@@ -748,7 +727,367 @@
           <a:lstStyle/>
           <a:p>
             <a:r>
-              <a:t>Siehe Trainerhandbuch (Sektion 3) für Moderationshinweise, Timing und erwartete Teilnehmerreaktionen.</a:t>
+              <a:t>Berechtigungstiefe ist hausindividuell. Im Zweifel klären, nicht selbst ändern – alles mit Bezug zur Kreditentscheidung ist tabu.</a:t>
+            </a:r>
+          </a:p>
+        </p:txBody>
+      </p:sp>
+      <p:sp>
+        <p:nvSpPr>
+          <p:cNvPr id="4" name="Slide Number Placeholder 3"/>
+          <p:cNvSpPr>
+            <a:spLocks noGrp="1"/>
+          </p:cNvSpPr>
+          <p:nvPr>
+            <p:ph type="sldNum" idx="5" sz="quarter"/>
+          </p:nvPr>
+        </p:nvSpPr>
+        <p:spPr/>
+      </p:sp>
+    </p:spTree>
+  </p:cSld>
+  <p:clrMapOvr>
+    <a:masterClrMapping/>
+  </p:clrMapOvr>
+</p:notes>
+</file>
+
+<file path=ppt/notesSlides/notesSlide5.xml><?xml version="1.0" encoding="utf-8"?>
+<p:notes xmlns:a="http://schemas.openxmlformats.org/drawingml/2006/main" xmlns:p="http://schemas.openxmlformats.org/presentationml/2006/main" xmlns:r="http://schemas.openxmlformats.org/officeDocument/2006/relationships">
+  <p:cSld>
+    <p:spTree>
+      <p:nvGrpSpPr>
+        <p:cNvPr id="1" name=""/>
+        <p:cNvGrpSpPr/>
+        <p:nvPr/>
+      </p:nvGrpSpPr>
+      <p:grpSpPr>
+        <a:xfrm>
+          <a:off x="0" y="0"/>
+          <a:ext cx="0" cy="0"/>
+          <a:chOff x="0" y="0"/>
+          <a:chExt cx="0" cy="0"/>
+        </a:xfrm>
+      </p:grpSpPr>
+      <p:sp>
+        <p:nvSpPr>
+          <p:cNvPr id="2" name="Slide Image Placeholder 1"/>
+          <p:cNvSpPr>
+            <a:spLocks noGrp="1"/>
+          </p:cNvSpPr>
+          <p:nvPr>
+            <p:ph type="sldImg" idx="2"/>
+          </p:nvPr>
+        </p:nvSpPr>
+        <p:spPr/>
+      </p:sp>
+      <p:sp>
+        <p:nvSpPr>
+          <p:cNvPr id="3" name="Notes Placeholder 2"/>
+          <p:cNvSpPr>
+            <a:spLocks noGrp="1"/>
+          </p:cNvSpPr>
+          <p:nvPr>
+            <p:ph type="body" idx="3" sz="quarter"/>
+          </p:nvPr>
+        </p:nvSpPr>
+        <p:spPr/>
+        <p:txBody>
+          <a:bodyPr/>
+          <a:lstStyle/>
+          <a:p>
+            <a:r>
+              <a:t>Aufgabe: die vier Befunde in eine begründete Bearbeitungsreihenfolge bringen. Beobachten: Wer priorisiert nach Risikoart, wer nach Reihenfolge/Zeitnähe?</a:t>
+            </a:r>
+          </a:p>
+        </p:txBody>
+      </p:sp>
+      <p:sp>
+        <p:nvSpPr>
+          <p:cNvPr id="4" name="Slide Number Placeholder 3"/>
+          <p:cNvSpPr>
+            <a:spLocks noGrp="1"/>
+          </p:cNvSpPr>
+          <p:nvPr>
+            <p:ph type="sldNum" idx="5" sz="quarter"/>
+          </p:nvPr>
+        </p:nvSpPr>
+        <p:spPr/>
+      </p:sp>
+    </p:spTree>
+  </p:cSld>
+  <p:clrMapOvr>
+    <a:masterClrMapping/>
+  </p:clrMapOvr>
+</p:notes>
+</file>
+
+<file path=ppt/notesSlides/notesSlide6.xml><?xml version="1.0" encoding="utf-8"?>
+<p:notes xmlns:a="http://schemas.openxmlformats.org/drawingml/2006/main" xmlns:p="http://schemas.openxmlformats.org/presentationml/2006/main" xmlns:r="http://schemas.openxmlformats.org/officeDocument/2006/relationships">
+  <p:cSld>
+    <p:spTree>
+      <p:nvGrpSpPr>
+        <p:cNvPr id="1" name=""/>
+        <p:cNvGrpSpPr/>
+        <p:nvPr/>
+      </p:nvGrpSpPr>
+      <p:grpSpPr>
+        <a:xfrm>
+          <a:off x="0" y="0"/>
+          <a:ext cx="0" cy="0"/>
+          <a:chOff x="0" y="0"/>
+          <a:chExt cx="0" cy="0"/>
+        </a:xfrm>
+      </p:grpSpPr>
+      <p:sp>
+        <p:nvSpPr>
+          <p:cNvPr id="2" name="Slide Image Placeholder 1"/>
+          <p:cNvSpPr>
+            <a:spLocks noGrp="1"/>
+          </p:cNvSpPr>
+          <p:nvPr>
+            <p:ph type="sldImg" idx="2"/>
+          </p:nvPr>
+        </p:nvSpPr>
+        <p:spPr/>
+      </p:sp>
+      <p:sp>
+        <p:nvSpPr>
+          <p:cNvPr id="3" name="Notes Placeholder 2"/>
+          <p:cNvSpPr>
+            <a:spLocks noGrp="1"/>
+          </p:cNvSpPr>
+          <p:nvPr>
+            <p:ph type="body" idx="3" sz="quarter"/>
+          </p:nvPr>
+        </p:nvSpPr>
+        <p:spPr/>
+        <p:txBody>
+          <a:bodyPr/>
+          <a:lstStyle/>
+          <a:p>
+            <a:r>
+              <a:t>Kernbotschaft: der § 18-Befund (Handel) ist Priorität 1 – nicht weil er zuerst steht, sondern weil er regulatorisch kritisch ist. Zinsbindung (Logistik) ist Frist UND Vertriebsanlass.</a:t>
+            </a:r>
+          </a:p>
+        </p:txBody>
+      </p:sp>
+      <p:sp>
+        <p:nvSpPr>
+          <p:cNvPr id="4" name="Slide Number Placeholder 3"/>
+          <p:cNvSpPr>
+            <a:spLocks noGrp="1"/>
+          </p:cNvSpPr>
+          <p:nvPr>
+            <p:ph type="sldNum" idx="5" sz="quarter"/>
+          </p:nvPr>
+        </p:nvSpPr>
+        <p:spPr/>
+      </p:sp>
+    </p:spTree>
+  </p:cSld>
+  <p:clrMapOvr>
+    <a:masterClrMapping/>
+  </p:clrMapOvr>
+</p:notes>
+</file>
+
+<file path=ppt/notesSlides/notesSlide7.xml><?xml version="1.0" encoding="utf-8"?>
+<p:notes xmlns:a="http://schemas.openxmlformats.org/drawingml/2006/main" xmlns:p="http://schemas.openxmlformats.org/presentationml/2006/main" xmlns:r="http://schemas.openxmlformats.org/officeDocument/2006/relationships">
+  <p:cSld>
+    <p:spTree>
+      <p:nvGrpSpPr>
+        <p:cNvPr id="1" name=""/>
+        <p:cNvGrpSpPr/>
+        <p:nvPr/>
+      </p:nvGrpSpPr>
+      <p:grpSpPr>
+        <a:xfrm>
+          <a:off x="0" y="0"/>
+          <a:ext cx="0" cy="0"/>
+          <a:chOff x="0" y="0"/>
+          <a:chExt cx="0" cy="0"/>
+        </a:xfrm>
+      </p:grpSpPr>
+      <p:sp>
+        <p:nvSpPr>
+          <p:cNvPr id="2" name="Slide Image Placeholder 1"/>
+          <p:cNvSpPr>
+            <a:spLocks noGrp="1"/>
+          </p:cNvSpPr>
+          <p:nvPr>
+            <p:ph type="sldImg" idx="2"/>
+          </p:nvPr>
+        </p:nvSpPr>
+        <p:spPr/>
+      </p:sp>
+      <p:sp>
+        <p:nvSpPr>
+          <p:cNvPr id="3" name="Notes Placeholder 2"/>
+          <p:cNvSpPr>
+            <a:spLocks noGrp="1"/>
+          </p:cNvSpPr>
+          <p:nvPr>
+            <p:ph type="body" idx="3" sz="quarter"/>
+          </p:nvPr>
+        </p:nvSpPr>
+        <p:spPr/>
+        <p:txBody>
+          <a:bodyPr/>
+          <a:lstStyle/>
+          <a:p>
+            <a:r>
+              <a:t>AB-1 Musterlösung (Trainer-Version)</a:t>
+            </a:r>
+          </a:p>
+          <a:p>
+            <a:r>
+              <a:t>Reihenfolge: 1. Handel (§ 18 überfällig, Meldepflicht), 2. Pflege (Sicherheiten-Frist 3 Wochen), 3. Logistik (Zinsbindung 6 Wochen, Anlass), 4. Technik (Datenpflege).</a:t>
+            </a:r>
+          </a:p>
+          <a:p>
+            <a:r>
+              <a:t>Trainer-Hinweis: „rechtssicher" bei AB-3 heißt Änderung über den erlaubten Weg mit dokumentierter Quelle – nicht heimlich überschreiben.</a:t>
+            </a:r>
+          </a:p>
+        </p:txBody>
+      </p:sp>
+      <p:sp>
+        <p:nvSpPr>
+          <p:cNvPr id="4" name="Slide Number Placeholder 3"/>
+          <p:cNvSpPr>
+            <a:spLocks noGrp="1"/>
+          </p:cNvSpPr>
+          <p:nvPr>
+            <p:ph type="sldNum" idx="5" sz="quarter"/>
+          </p:nvPr>
+        </p:nvSpPr>
+        <p:spPr/>
+      </p:sp>
+    </p:spTree>
+  </p:cSld>
+  <p:clrMapOvr>
+    <a:masterClrMapping/>
+  </p:clrMapOvr>
+</p:notes>
+</file>
+
+<file path=ppt/notesSlides/notesSlide8.xml><?xml version="1.0" encoding="utf-8"?>
+<p:notes xmlns:a="http://schemas.openxmlformats.org/drawingml/2006/main" xmlns:p="http://schemas.openxmlformats.org/presentationml/2006/main" xmlns:r="http://schemas.openxmlformats.org/officeDocument/2006/relationships">
+  <p:cSld>
+    <p:spTree>
+      <p:nvGrpSpPr>
+        <p:cNvPr id="1" name=""/>
+        <p:cNvGrpSpPr/>
+        <p:nvPr/>
+      </p:nvGrpSpPr>
+      <p:grpSpPr>
+        <a:xfrm>
+          <a:off x="0" y="0"/>
+          <a:ext cx="0" cy="0"/>
+          <a:chOff x="0" y="0"/>
+          <a:chExt cx="0" cy="0"/>
+        </a:xfrm>
+      </p:grpSpPr>
+      <p:sp>
+        <p:nvSpPr>
+          <p:cNvPr id="2" name="Slide Image Placeholder 1"/>
+          <p:cNvSpPr>
+            <a:spLocks noGrp="1"/>
+          </p:cNvSpPr>
+          <p:nvPr>
+            <p:ph type="sldImg" idx="2"/>
+          </p:nvPr>
+        </p:nvSpPr>
+        <p:spPr/>
+      </p:sp>
+      <p:sp>
+        <p:nvSpPr>
+          <p:cNvPr id="3" name="Notes Placeholder 2"/>
+          <p:cNvSpPr>
+            <a:spLocks noGrp="1"/>
+          </p:cNvSpPr>
+          <p:nvPr>
+            <p:ph type="body" idx="3" sz="quarter"/>
+          </p:nvPr>
+        </p:nvSpPr>
+        <p:spPr/>
+        <p:txBody>
+          <a:bodyPr/>
+          <a:lstStyle/>
+          <a:p>
+            <a:r>
+              <a:t>Überleitung: Karte AB-5 als Tisch-Werkzeug für morgen. Ausblick VA09 – Vertriebsanlässe aus sauberen Beständen erkennen.</a:t>
+            </a:r>
+          </a:p>
+        </p:txBody>
+      </p:sp>
+      <p:sp>
+        <p:nvSpPr>
+          <p:cNvPr id="4" name="Slide Number Placeholder 3"/>
+          <p:cNvSpPr>
+            <a:spLocks noGrp="1"/>
+          </p:cNvSpPr>
+          <p:nvPr>
+            <p:ph type="sldNum" idx="5" sz="quarter"/>
+          </p:nvPr>
+        </p:nvSpPr>
+        <p:spPr/>
+      </p:sp>
+    </p:spTree>
+  </p:cSld>
+  <p:clrMapOvr>
+    <a:masterClrMapping/>
+  </p:clrMapOvr>
+</p:notes>
+</file>
+
+<file path=ppt/notesSlides/notesSlide9.xml><?xml version="1.0" encoding="utf-8"?>
+<p:notes xmlns:a="http://schemas.openxmlformats.org/drawingml/2006/main" xmlns:p="http://schemas.openxmlformats.org/presentationml/2006/main" xmlns:r="http://schemas.openxmlformats.org/officeDocument/2006/relationships">
+  <p:cSld>
+    <p:spTree>
+      <p:nvGrpSpPr>
+        <p:cNvPr id="1" name=""/>
+        <p:cNvGrpSpPr/>
+        <p:nvPr/>
+      </p:nvGrpSpPr>
+      <p:grpSpPr>
+        <a:xfrm>
+          <a:off x="0" y="0"/>
+          <a:ext cx="0" cy="0"/>
+          <a:chOff x="0" y="0"/>
+          <a:chExt cx="0" cy="0"/>
+        </a:xfrm>
+      </p:grpSpPr>
+      <p:sp>
+        <p:nvSpPr>
+          <p:cNvPr id="2" name="Slide Image Placeholder 1"/>
+          <p:cNvSpPr>
+            <a:spLocks noGrp="1"/>
+          </p:cNvSpPr>
+          <p:nvPr>
+            <p:ph type="sldImg" idx="2"/>
+          </p:nvPr>
+        </p:nvSpPr>
+        <p:spPr/>
+      </p:sp>
+      <p:sp>
+        <p:nvSpPr>
+          <p:cNvPr id="3" name="Notes Placeholder 2"/>
+          <p:cNvSpPr>
+            <a:spLocks noGrp="1"/>
+          </p:cNvSpPr>
+          <p:nvPr>
+            <p:ph type="body" idx="3" sz="quarter"/>
+          </p:nvPr>
+        </p:nvSpPr>
+        <p:spPr/>
+        <p:txBody>
+          <a:bodyPr/>
+          <a:lstStyle/>
+          <a:p>
+            <a:r>
+              <a:t>Fragen 1 und 3 im Plenum, ca. 4 Min. je. Transferaufgabe (30 Tage) kurz vorstellen.</a:t>
             </a:r>
           </a:p>
         </p:txBody>
@@ -4319,6 +4658,2810 @@
 </p:sld>
 </file>
 
+<file path=ppt/slides/slide10.xml><?xml version="1.0" encoding="utf-8"?>
+<p:sld xmlns:a="http://schemas.openxmlformats.org/drawingml/2006/main" xmlns:p="http://schemas.openxmlformats.org/presentationml/2006/main" xmlns:r="http://schemas.openxmlformats.org/officeDocument/2006/relationships">
+  <p:cSld>
+    <p:spTree>
+      <p:nvGrpSpPr>
+        <p:cNvPr id="1" name=""/>
+        <p:cNvGrpSpPr/>
+        <p:nvPr/>
+      </p:nvGrpSpPr>
+      <p:grpSpPr/>
+      <p:sp>
+        <p:nvSpPr>
+          <p:cNvPr id="2" name="Rectangle 1"/>
+          <p:cNvSpPr/>
+          <p:nvPr/>
+        </p:nvSpPr>
+        <p:spPr>
+          <a:xfrm>
+            <a:off x="0" y="0"/>
+            <a:ext cx="12188952" cy="6858000"/>
+          </a:xfrm>
+          <a:prstGeom prst="rect">
+            <a:avLst/>
+          </a:prstGeom>
+          <a:solidFill>
+            <a:srgbClr val="FFFFFF"/>
+          </a:solidFill>
+          <a:ln>
+            <a:noFill/>
+          </a:ln>
+        </p:spPr>
+        <p:style>
+          <a:lnRef idx="1">
+            <a:schemeClr val="accent1"/>
+          </a:lnRef>
+          <a:fillRef idx="3">
+            <a:schemeClr val="accent1"/>
+          </a:fillRef>
+          <a:effectRef idx="2">
+            <a:schemeClr val="accent1"/>
+          </a:effectRef>
+          <a:fontRef idx="minor">
+            <a:schemeClr val="lt1"/>
+          </a:fontRef>
+        </p:style>
+        <p:txBody>
+          <a:bodyPr rtlCol="0" anchor="ctr"/>
+          <a:lstStyle/>
+          <a:p>
+            <a:pPr algn="ctr"/>
+          </a:p>
+        </p:txBody>
+      </p:sp>
+      <p:sp>
+        <p:nvSpPr>
+          <p:cNvPr id="3" name="Rectangle 2"/>
+          <p:cNvSpPr/>
+          <p:nvPr/>
+        </p:nvSpPr>
+        <p:spPr>
+          <a:xfrm>
+            <a:off x="0" y="0"/>
+            <a:ext cx="12188952" cy="50292"/>
+          </a:xfrm>
+          <a:prstGeom prst="rect">
+            <a:avLst/>
+          </a:prstGeom>
+          <a:solidFill>
+            <a:srgbClr val="1F2C56"/>
+          </a:solidFill>
+          <a:ln>
+            <a:noFill/>
+          </a:ln>
+        </p:spPr>
+        <p:style>
+          <a:lnRef idx="1">
+            <a:schemeClr val="accent1"/>
+          </a:lnRef>
+          <a:fillRef idx="3">
+            <a:schemeClr val="accent1"/>
+          </a:fillRef>
+          <a:effectRef idx="2">
+            <a:schemeClr val="accent1"/>
+          </a:effectRef>
+          <a:fontRef idx="minor">
+            <a:schemeClr val="lt1"/>
+          </a:fontRef>
+        </p:style>
+        <p:txBody>
+          <a:bodyPr rtlCol="0" anchor="ctr"/>
+          <a:lstStyle/>
+          <a:p>
+            <a:pPr algn="ctr"/>
+          </a:p>
+        </p:txBody>
+      </p:sp>
+      <p:sp>
+        <p:nvSpPr>
+          <p:cNvPr id="4" name="TextBox 3"/>
+          <p:cNvSpPr txBox="1"/>
+          <p:nvPr/>
+        </p:nvSpPr>
+        <p:spPr>
+          <a:xfrm>
+            <a:off x="685800" y="109728"/>
+            <a:ext cx="10817352" cy="228600"/>
+          </a:xfrm>
+          <a:prstGeom prst="rect">
+            <a:avLst/>
+          </a:prstGeom>
+          <a:noFill/>
+        </p:spPr>
+        <p:txBody>
+          <a:bodyPr wrap="none">
+            <a:spAutoFit/>
+          </a:bodyPr>
+          <a:lstStyle/>
+          <a:p>
+            <a:pPr algn="l"/>
+            <a:r>
+              <a:rPr sz="750">
+                <a:solidFill>
+                  <a:srgbClr val="78808C"/>
+                </a:solidFill>
+                <a:latin typeface="Consolas"/>
+              </a:rPr>
+              <a:t>VA04  ·  SCHAUBILD</a:t>
+            </a:r>
+          </a:p>
+        </p:txBody>
+      </p:sp>
+      <p:sp>
+        <p:nvSpPr>
+          <p:cNvPr id="5" name="TextBox 4"/>
+          <p:cNvSpPr txBox="1"/>
+          <p:nvPr/>
+        </p:nvSpPr>
+        <p:spPr>
+          <a:xfrm>
+            <a:off x="685800" y="502920"/>
+            <a:ext cx="10817352" cy="594360"/>
+          </a:xfrm>
+          <a:prstGeom prst="rect">
+            <a:avLst/>
+          </a:prstGeom>
+          <a:noFill/>
+        </p:spPr>
+        <p:txBody>
+          <a:bodyPr wrap="square">
+            <a:spAutoFit/>
+          </a:bodyPr>
+          <a:lstStyle/>
+          <a:p>
+            <a:pPr algn="l"/>
+            <a:r>
+              <a:rPr sz="2000" b="1" i="0">
+                <a:solidFill>
+                  <a:srgbClr val="1F2C56"/>
+                </a:solidFill>
+                <a:latin typeface="Arial"/>
+              </a:rPr>
+              <a:t>Datenqualität: Was darf ich selbst ändern?</a:t>
+            </a:r>
+          </a:p>
+        </p:txBody>
+      </p:sp>
+      <p:sp>
+        <p:nvSpPr>
+          <p:cNvPr id="6" name="Rectangle 5"/>
+          <p:cNvSpPr/>
+          <p:nvPr/>
+        </p:nvSpPr>
+        <p:spPr>
+          <a:xfrm>
+            <a:off x="685800" y="1143000"/>
+            <a:ext cx="10817352" cy="25400"/>
+          </a:xfrm>
+          <a:prstGeom prst="rect">
+            <a:avLst/>
+          </a:prstGeom>
+          <a:solidFill>
+            <a:srgbClr val="D9C089"/>
+          </a:solidFill>
+          <a:ln>
+            <a:noFill/>
+          </a:ln>
+        </p:spPr>
+        <p:style>
+          <a:lnRef idx="1">
+            <a:schemeClr val="accent1"/>
+          </a:lnRef>
+          <a:fillRef idx="3">
+            <a:schemeClr val="accent1"/>
+          </a:fillRef>
+          <a:effectRef idx="2">
+            <a:schemeClr val="accent1"/>
+          </a:effectRef>
+          <a:fontRef idx="minor">
+            <a:schemeClr val="lt1"/>
+          </a:fontRef>
+        </p:style>
+        <p:txBody>
+          <a:bodyPr rtlCol="0" anchor="ctr"/>
+          <a:lstStyle/>
+          <a:p>
+            <a:pPr algn="ctr"/>
+          </a:p>
+        </p:txBody>
+      </p:sp>
+      <p:pic>
+        <p:nvPicPr>
+          <p:cNvPr id="7" name="Picture 6" descr="image.png"/>
+          <p:cNvPicPr>
+            <a:picLocks noChangeAspect="1"/>
+          </p:cNvPicPr>
+          <p:nvPr/>
+        </p:nvPicPr>
+        <p:blipFill>
+          <a:blip r:embed="rId2"/>
+          <a:stretch>
+            <a:fillRect/>
+          </a:stretch>
+        </p:blipFill>
+        <p:spPr>
+          <a:xfrm>
+            <a:off x="2009463" y="1325880"/>
+            <a:ext cx="8170026" cy="4937760"/>
+          </a:xfrm>
+          <a:prstGeom prst="rect">
+            <a:avLst/>
+          </a:prstGeom>
+        </p:spPr>
+      </p:pic>
+      <p:sp>
+        <p:nvSpPr>
+          <p:cNvPr id="8" name="Rectangle 7"/>
+          <p:cNvSpPr/>
+          <p:nvPr/>
+        </p:nvSpPr>
+        <p:spPr>
+          <a:xfrm>
+            <a:off x="0" y="6510528"/>
+            <a:ext cx="12188952" cy="347472"/>
+          </a:xfrm>
+          <a:prstGeom prst="rect">
+            <a:avLst/>
+          </a:prstGeom>
+          <a:solidFill>
+            <a:srgbClr val="0A1937"/>
+          </a:solidFill>
+          <a:ln>
+            <a:noFill/>
+          </a:ln>
+        </p:spPr>
+        <p:style>
+          <a:lnRef idx="1">
+            <a:schemeClr val="accent1"/>
+          </a:lnRef>
+          <a:fillRef idx="3">
+            <a:schemeClr val="accent1"/>
+          </a:fillRef>
+          <a:effectRef idx="2">
+            <a:schemeClr val="accent1"/>
+          </a:effectRef>
+          <a:fontRef idx="minor">
+            <a:schemeClr val="lt1"/>
+          </a:fontRef>
+        </p:style>
+        <p:txBody>
+          <a:bodyPr rtlCol="0" anchor="ctr"/>
+          <a:lstStyle/>
+          <a:p>
+            <a:pPr algn="ctr"/>
+          </a:p>
+        </p:txBody>
+      </p:sp>
+      <p:sp>
+        <p:nvSpPr>
+          <p:cNvPr id="9" name="TextBox 8"/>
+          <p:cNvSpPr txBox="1"/>
+          <p:nvPr/>
+        </p:nvSpPr>
+        <p:spPr>
+          <a:xfrm>
+            <a:off x="685800" y="6583680"/>
+            <a:ext cx="6490411" cy="256032"/>
+          </a:xfrm>
+          <a:prstGeom prst="rect">
+            <a:avLst/>
+          </a:prstGeom>
+          <a:noFill/>
+        </p:spPr>
+        <p:txBody>
+          <a:bodyPr wrap="none">
+            <a:spAutoFit/>
+          </a:bodyPr>
+          <a:lstStyle/>
+          <a:p>
+            <a:pPr algn="l"/>
+            <a:r>
+              <a:rPr sz="700">
+                <a:solidFill>
+                  <a:srgbClr val="A0B4D2"/>
+                </a:solidFill>
+                <a:latin typeface="Consolas"/>
+              </a:rPr>
+              <a:t>FKB Campus  ·  VA04</a:t>
+            </a:r>
+          </a:p>
+        </p:txBody>
+      </p:sp>
+      <p:sp>
+        <p:nvSpPr>
+          <p:cNvPr id="10" name="TextBox 9"/>
+          <p:cNvSpPr txBox="1"/>
+          <p:nvPr/>
+        </p:nvSpPr>
+        <p:spPr>
+          <a:xfrm>
+            <a:off x="7176211" y="6583680"/>
+            <a:ext cx="4326940" cy="256032"/>
+          </a:xfrm>
+          <a:prstGeom prst="rect">
+            <a:avLst/>
+          </a:prstGeom>
+          <a:noFill/>
+        </p:spPr>
+        <p:txBody>
+          <a:bodyPr wrap="none">
+            <a:spAutoFit/>
+          </a:bodyPr>
+          <a:lstStyle/>
+          <a:p>
+            <a:pPr algn="r"/>
+            <a:r>
+              <a:rPr sz="700">
+                <a:solidFill>
+                  <a:srgbClr val="A0B4D2"/>
+                </a:solidFill>
+                <a:latin typeface="Consolas"/>
+              </a:rPr>
+              <a:t>Schaubild</a:t>
+            </a:r>
+          </a:p>
+        </p:txBody>
+      </p:sp>
+    </p:spTree>
+  </p:cSld>
+  <p:clrMapOvr>
+    <a:masterClrMapping/>
+  </p:clrMapOvr>
+</p:sld>
+</file>
+
+<file path=ppt/slides/slide11.xml><?xml version="1.0" encoding="utf-8"?>
+<p:sld xmlns:a="http://schemas.openxmlformats.org/drawingml/2006/main" xmlns:p="http://schemas.openxmlformats.org/presentationml/2006/main" xmlns:r="http://schemas.openxmlformats.org/officeDocument/2006/relationships">
+  <p:cSld>
+    <p:spTree>
+      <p:nvGrpSpPr>
+        <p:cNvPr id="1" name=""/>
+        <p:cNvGrpSpPr/>
+        <p:nvPr/>
+      </p:nvGrpSpPr>
+      <p:grpSpPr/>
+      <p:sp>
+        <p:nvSpPr>
+          <p:cNvPr id="2" name="Rectangle 1"/>
+          <p:cNvSpPr/>
+          <p:nvPr/>
+        </p:nvSpPr>
+        <p:spPr>
+          <a:xfrm>
+            <a:off x="0" y="0"/>
+            <a:ext cx="12188952" cy="6858000"/>
+          </a:xfrm>
+          <a:prstGeom prst="rect">
+            <a:avLst/>
+          </a:prstGeom>
+          <a:solidFill>
+            <a:srgbClr val="1F2C56"/>
+          </a:solidFill>
+          <a:ln>
+            <a:noFill/>
+          </a:ln>
+        </p:spPr>
+        <p:style>
+          <a:lnRef idx="1">
+            <a:schemeClr val="accent1"/>
+          </a:lnRef>
+          <a:fillRef idx="3">
+            <a:schemeClr val="accent1"/>
+          </a:fillRef>
+          <a:effectRef idx="2">
+            <a:schemeClr val="accent1"/>
+          </a:effectRef>
+          <a:fontRef idx="minor">
+            <a:schemeClr val="lt1"/>
+          </a:fontRef>
+        </p:style>
+        <p:txBody>
+          <a:bodyPr rtlCol="0" anchor="ctr"/>
+          <a:lstStyle/>
+          <a:p>
+            <a:pPr algn="ctr"/>
+          </a:p>
+        </p:txBody>
+      </p:sp>
+      <p:sp>
+        <p:nvSpPr>
+          <p:cNvPr id="3" name="TextBox 2"/>
+          <p:cNvSpPr txBox="1"/>
+          <p:nvPr/>
+        </p:nvSpPr>
+        <p:spPr>
+          <a:xfrm>
+            <a:off x="685800" y="2377440"/>
+            <a:ext cx="10817352" cy="365760"/>
+          </a:xfrm>
+          <a:prstGeom prst="rect">
+            <a:avLst/>
+          </a:prstGeom>
+          <a:noFill/>
+        </p:spPr>
+        <p:txBody>
+          <a:bodyPr wrap="none">
+            <a:spAutoFit/>
+          </a:bodyPr>
+          <a:lstStyle/>
+          <a:p>
+            <a:pPr algn="l"/>
+            <a:r>
+              <a:rPr sz="1200">
+                <a:solidFill>
+                  <a:srgbClr val="D9C089"/>
+                </a:solidFill>
+                <a:latin typeface="Consolas"/>
+              </a:rPr>
+              <a:t>00:30–01:20</a:t>
+            </a:r>
+          </a:p>
+        </p:txBody>
+      </p:sp>
+      <p:sp>
+        <p:nvSpPr>
+          <p:cNvPr id="4" name="Rectangle 3"/>
+          <p:cNvSpPr/>
+          <p:nvPr/>
+        </p:nvSpPr>
+        <p:spPr>
+          <a:xfrm>
+            <a:off x="685800" y="2788920"/>
+            <a:ext cx="548640" cy="38100"/>
+          </a:xfrm>
+          <a:prstGeom prst="rect">
+            <a:avLst/>
+          </a:prstGeom>
+          <a:solidFill>
+            <a:srgbClr val="D9C089"/>
+          </a:solidFill>
+          <a:ln>
+            <a:noFill/>
+          </a:ln>
+        </p:spPr>
+        <p:style>
+          <a:lnRef idx="1">
+            <a:schemeClr val="accent1"/>
+          </a:lnRef>
+          <a:fillRef idx="3">
+            <a:schemeClr val="accent1"/>
+          </a:fillRef>
+          <a:effectRef idx="2">
+            <a:schemeClr val="accent1"/>
+          </a:effectRef>
+          <a:fontRef idx="minor">
+            <a:schemeClr val="lt1"/>
+          </a:fontRef>
+        </p:style>
+        <p:txBody>
+          <a:bodyPr rtlCol="0" anchor="ctr"/>
+          <a:lstStyle/>
+          <a:p>
+            <a:pPr algn="ctr"/>
+          </a:p>
+        </p:txBody>
+      </p:sp>
+      <p:sp>
+        <p:nvSpPr>
+          <p:cNvPr id="5" name="TextBox 4"/>
+          <p:cNvSpPr txBox="1"/>
+          <p:nvPr/>
+        </p:nvSpPr>
+        <p:spPr>
+          <a:xfrm>
+            <a:off x="685800" y="3017520"/>
+            <a:ext cx="10817352" cy="1463040"/>
+          </a:xfrm>
+          <a:prstGeom prst="rect">
+            <a:avLst/>
+          </a:prstGeom>
+          <a:noFill/>
+        </p:spPr>
+        <p:txBody>
+          <a:bodyPr wrap="square">
+            <a:spAutoFit/>
+          </a:bodyPr>
+          <a:lstStyle/>
+          <a:p>
+            <a:pPr algn="l"/>
+            <a:r>
+              <a:rPr sz="4000" b="1" i="0">
+                <a:solidFill>
+                  <a:srgbClr val="FFFFFF"/>
+                </a:solidFill>
+                <a:latin typeface="Arial"/>
+              </a:rPr>
+              <a:t>Fallübergabe &amp; Fallarbeit</a:t>
+            </a:r>
+          </a:p>
+        </p:txBody>
+      </p:sp>
+      <p:sp>
+        <p:nvSpPr>
+          <p:cNvPr id="6" name="TextBox 5"/>
+          <p:cNvSpPr txBox="1"/>
+          <p:nvPr/>
+        </p:nvSpPr>
+        <p:spPr>
+          <a:xfrm>
+            <a:off x="685800" y="4480560"/>
+            <a:ext cx="8653881" cy="1280160"/>
+          </a:xfrm>
+          <a:prstGeom prst="rect">
+            <a:avLst/>
+          </a:prstGeom>
+          <a:noFill/>
+        </p:spPr>
+        <p:txBody>
+          <a:bodyPr wrap="square">
+            <a:spAutoFit/>
+          </a:bodyPr>
+          <a:lstStyle/>
+          <a:p>
+            <a:pPr algn="l"/>
+            <a:r>
+              <a:rPr sz="1600" b="0" i="0">
+                <a:solidFill>
+                  <a:srgbClr val="C8D2E6"/>
+                </a:solidFill>
+                <a:latin typeface="Arial"/>
+              </a:rPr>
+              <a:t>Vier Kunden, vier Befunde – in welcher Reihenfolge bearbeiten Sie sie?</a:t>
+            </a:r>
+          </a:p>
+        </p:txBody>
+      </p:sp>
+      <p:sp>
+        <p:nvSpPr>
+          <p:cNvPr id="7" name="TextBox 6"/>
+          <p:cNvSpPr txBox="1"/>
+          <p:nvPr/>
+        </p:nvSpPr>
+        <p:spPr>
+          <a:xfrm>
+            <a:off x="685800" y="6355080"/>
+            <a:ext cx="10817352" cy="274320"/>
+          </a:xfrm>
+          <a:prstGeom prst="rect">
+            <a:avLst/>
+          </a:prstGeom>
+          <a:noFill/>
+        </p:spPr>
+        <p:txBody>
+          <a:bodyPr wrap="none">
+            <a:spAutoFit/>
+          </a:bodyPr>
+          <a:lstStyle/>
+          <a:p>
+            <a:pPr algn="l"/>
+            <a:r>
+              <a:rPr sz="700">
+                <a:solidFill>
+                  <a:srgbClr val="8CA0C3"/>
+                </a:solidFill>
+                <a:latin typeface="Consolas"/>
+              </a:rPr>
+              <a:t>FKB Campus  ·  VA04</a:t>
+            </a:r>
+          </a:p>
+        </p:txBody>
+      </p:sp>
+    </p:spTree>
+  </p:cSld>
+  <p:clrMapOvr>
+    <a:masterClrMapping/>
+  </p:clrMapOvr>
+</p:sld>
+</file>
+
+<file path=ppt/slides/slide12.xml><?xml version="1.0" encoding="utf-8"?>
+<p:sld xmlns:a="http://schemas.openxmlformats.org/drawingml/2006/main" xmlns:p="http://schemas.openxmlformats.org/presentationml/2006/main" xmlns:r="http://schemas.openxmlformats.org/officeDocument/2006/relationships">
+  <p:cSld>
+    <p:spTree>
+      <p:nvGrpSpPr>
+        <p:cNvPr id="1" name=""/>
+        <p:cNvGrpSpPr/>
+        <p:nvPr/>
+      </p:nvGrpSpPr>
+      <p:grpSpPr/>
+      <p:sp>
+        <p:nvSpPr>
+          <p:cNvPr id="2" name="Rectangle 1"/>
+          <p:cNvSpPr/>
+          <p:nvPr/>
+        </p:nvSpPr>
+        <p:spPr>
+          <a:xfrm>
+            <a:off x="0" y="0"/>
+            <a:ext cx="12188952" cy="6858000"/>
+          </a:xfrm>
+          <a:prstGeom prst="rect">
+            <a:avLst/>
+          </a:prstGeom>
+          <a:solidFill>
+            <a:srgbClr val="EDEDF3"/>
+          </a:solidFill>
+          <a:ln>
+            <a:noFill/>
+          </a:ln>
+        </p:spPr>
+        <p:style>
+          <a:lnRef idx="1">
+            <a:schemeClr val="accent1"/>
+          </a:lnRef>
+          <a:fillRef idx="3">
+            <a:schemeClr val="accent1"/>
+          </a:fillRef>
+          <a:effectRef idx="2">
+            <a:schemeClr val="accent1"/>
+          </a:effectRef>
+          <a:fontRef idx="minor">
+            <a:schemeClr val="lt1"/>
+          </a:fontRef>
+        </p:style>
+        <p:txBody>
+          <a:bodyPr rtlCol="0" anchor="ctr"/>
+          <a:lstStyle/>
+          <a:p>
+            <a:pPr algn="ctr"/>
+          </a:p>
+        </p:txBody>
+      </p:sp>
+      <p:sp>
+        <p:nvSpPr>
+          <p:cNvPr id="3" name="Rectangle 2"/>
+          <p:cNvSpPr/>
+          <p:nvPr/>
+        </p:nvSpPr>
+        <p:spPr>
+          <a:xfrm>
+            <a:off x="0" y="0"/>
+            <a:ext cx="12188952" cy="50292"/>
+          </a:xfrm>
+          <a:prstGeom prst="rect">
+            <a:avLst/>
+          </a:prstGeom>
+          <a:solidFill>
+            <a:srgbClr val="1F2C56"/>
+          </a:solidFill>
+          <a:ln>
+            <a:noFill/>
+          </a:ln>
+        </p:spPr>
+        <p:style>
+          <a:lnRef idx="1">
+            <a:schemeClr val="accent1"/>
+          </a:lnRef>
+          <a:fillRef idx="3">
+            <a:schemeClr val="accent1"/>
+          </a:fillRef>
+          <a:effectRef idx="2">
+            <a:schemeClr val="accent1"/>
+          </a:effectRef>
+          <a:fontRef idx="minor">
+            <a:schemeClr val="lt1"/>
+          </a:fontRef>
+        </p:style>
+        <p:txBody>
+          <a:bodyPr rtlCol="0" anchor="ctr"/>
+          <a:lstStyle/>
+          <a:p>
+            <a:pPr algn="ctr"/>
+          </a:p>
+        </p:txBody>
+      </p:sp>
+      <p:sp>
+        <p:nvSpPr>
+          <p:cNvPr id="4" name="TextBox 3"/>
+          <p:cNvSpPr txBox="1"/>
+          <p:nvPr/>
+        </p:nvSpPr>
+        <p:spPr>
+          <a:xfrm>
+            <a:off x="685800" y="109728"/>
+            <a:ext cx="10817352" cy="228600"/>
+          </a:xfrm>
+          <a:prstGeom prst="rect">
+            <a:avLst/>
+          </a:prstGeom>
+          <a:noFill/>
+        </p:spPr>
+        <p:txBody>
+          <a:bodyPr wrap="none">
+            <a:spAutoFit/>
+          </a:bodyPr>
+          <a:lstStyle/>
+          <a:p>
+            <a:pPr algn="l"/>
+            <a:r>
+              <a:rPr sz="750">
+                <a:solidFill>
+                  <a:srgbClr val="78808C"/>
+                </a:solidFill>
+                <a:latin typeface="Consolas"/>
+              </a:rPr>
+              <a:t>VA04  ·  INHALT</a:t>
+            </a:r>
+          </a:p>
+        </p:txBody>
+      </p:sp>
+      <p:sp>
+        <p:nvSpPr>
+          <p:cNvPr id="5" name="Rectangle 4"/>
+          <p:cNvSpPr/>
+          <p:nvPr/>
+        </p:nvSpPr>
+        <p:spPr>
+          <a:xfrm>
+            <a:off x="0" y="1234440"/>
+            <a:ext cx="12188952" cy="12700"/>
+          </a:xfrm>
+          <a:prstGeom prst="rect">
+            <a:avLst/>
+          </a:prstGeom>
+          <a:solidFill>
+            <a:srgbClr val="D8DFE4"/>
+          </a:solidFill>
+          <a:ln>
+            <a:noFill/>
+          </a:ln>
+        </p:spPr>
+        <p:style>
+          <a:lnRef idx="1">
+            <a:schemeClr val="accent1"/>
+          </a:lnRef>
+          <a:fillRef idx="3">
+            <a:schemeClr val="accent1"/>
+          </a:fillRef>
+          <a:effectRef idx="2">
+            <a:schemeClr val="accent1"/>
+          </a:effectRef>
+          <a:fontRef idx="minor">
+            <a:schemeClr val="lt1"/>
+          </a:fontRef>
+        </p:style>
+        <p:txBody>
+          <a:bodyPr rtlCol="0" anchor="ctr"/>
+          <a:lstStyle/>
+          <a:p>
+            <a:pPr algn="ctr"/>
+          </a:p>
+        </p:txBody>
+      </p:sp>
+      <p:sp>
+        <p:nvSpPr>
+          <p:cNvPr id="6" name="Rectangle 5"/>
+          <p:cNvSpPr/>
+          <p:nvPr/>
+        </p:nvSpPr>
+        <p:spPr>
+          <a:xfrm>
+            <a:off x="685800" y="502920"/>
+            <a:ext cx="36576" cy="658368"/>
+          </a:xfrm>
+          <a:prstGeom prst="rect">
+            <a:avLst/>
+          </a:prstGeom>
+          <a:solidFill>
+            <a:srgbClr val="D9C089"/>
+          </a:solidFill>
+          <a:ln>
+            <a:noFill/>
+          </a:ln>
+        </p:spPr>
+        <p:style>
+          <a:lnRef idx="1">
+            <a:schemeClr val="accent1"/>
+          </a:lnRef>
+          <a:fillRef idx="3">
+            <a:schemeClr val="accent1"/>
+          </a:fillRef>
+          <a:effectRef idx="2">
+            <a:schemeClr val="accent1"/>
+          </a:effectRef>
+          <a:fontRef idx="minor">
+            <a:schemeClr val="lt1"/>
+          </a:fontRef>
+        </p:style>
+        <p:txBody>
+          <a:bodyPr rtlCol="0" anchor="ctr"/>
+          <a:lstStyle/>
+          <a:p>
+            <a:pPr algn="ctr"/>
+          </a:p>
+        </p:txBody>
+      </p:sp>
+      <p:sp>
+        <p:nvSpPr>
+          <p:cNvPr id="7" name="TextBox 6"/>
+          <p:cNvSpPr txBox="1"/>
+          <p:nvPr/>
+        </p:nvSpPr>
+        <p:spPr>
+          <a:xfrm>
+            <a:off x="813816" y="502920"/>
+            <a:ext cx="10634472" cy="685800"/>
+          </a:xfrm>
+          <a:prstGeom prst="rect">
+            <a:avLst/>
+          </a:prstGeom>
+          <a:noFill/>
+        </p:spPr>
+        <p:txBody>
+          <a:bodyPr wrap="square">
+            <a:spAutoFit/>
+          </a:bodyPr>
+          <a:lstStyle/>
+          <a:p>
+            <a:pPr algn="l"/>
+            <a:r>
+              <a:rPr sz="2400" b="1" i="0">
+                <a:solidFill>
+                  <a:srgbClr val="1F2C56"/>
+                </a:solidFill>
+                <a:latin typeface="Arial"/>
+              </a:rPr>
+              <a:t>Praxisfall: Portfolio-Ausschnitt</a:t>
+            </a:r>
+          </a:p>
+        </p:txBody>
+      </p:sp>
+      <p:sp>
+        <p:nvSpPr>
+          <p:cNvPr id="8" name="TextBox 7"/>
+          <p:cNvSpPr txBox="1"/>
+          <p:nvPr/>
+        </p:nvSpPr>
+        <p:spPr>
+          <a:xfrm>
+            <a:off x="685800" y="1417320"/>
+            <a:ext cx="10817352" cy="4892040"/>
+          </a:xfrm>
+          <a:prstGeom prst="rect">
+            <a:avLst/>
+          </a:prstGeom>
+          <a:noFill/>
+        </p:spPr>
+        <p:txBody>
+          <a:bodyPr wrap="square" anchor="ctr">
+            <a:spAutoFit/>
+          </a:bodyPr>
+          <a:lstStyle/>
+          <a:p>
+            <a:pPr>
+              <a:spcBef>
+                <a:spcPts val="1000"/>
+              </a:spcBef>
+              <a:spcAft>
+                <a:spcPts val="200"/>
+              </a:spcAft>
+            </a:pPr>
+            <a:r>
+              <a:rPr sz="800" b="1">
+                <a:solidFill>
+                  <a:srgbClr val="78808C"/>
+                </a:solidFill>
+                <a:latin typeface="Consolas"/>
+              </a:rPr>
+              <a:t>VIER BEFUNDE AUF IHREM TISCH</a:t>
+            </a:r>
+          </a:p>
+          <a:p>
+            <a:pPr marL="190500" indent="-190500">
+              <a:spcBef>
+                <a:spcPts val="400"/>
+              </a:spcBef>
+              <a:spcAft>
+                <a:spcPts val="200"/>
+              </a:spcAft>
+            </a:pPr>
+            <a:r>
+              <a:rPr sz="1300">
+                <a:solidFill>
+                  <a:srgbClr val="3D5466"/>
+                </a:solidFill>
+                <a:latin typeface="Arial"/>
+              </a:rPr>
+              <a:t>▸  Handel Musterregion GmbH: § 18-Jahresabschluss seit 14 Monaten überfällig.</a:t>
+            </a:r>
+          </a:p>
+          <a:p>
+            <a:pPr marL="190500" indent="-190500">
+              <a:spcBef>
+                <a:spcPts val="400"/>
+              </a:spcBef>
+              <a:spcAft>
+                <a:spcPts val="200"/>
+              </a:spcAft>
+            </a:pPr>
+            <a:r>
+              <a:rPr sz="1300">
+                <a:solidFill>
+                  <a:srgbClr val="3D5466"/>
+                </a:solidFill>
+                <a:latin typeface="Arial"/>
+              </a:rPr>
+              <a:t>▸  Logistik Musterregion GmbH: Zinsbindung läuft in 6 Wochen aus, keine Wiedervorlage.</a:t>
+            </a:r>
+          </a:p>
+          <a:p>
+            <a:pPr marL="190500" indent="-190500">
+              <a:spcBef>
+                <a:spcPts val="400"/>
+              </a:spcBef>
+              <a:spcAft>
+                <a:spcPts val="200"/>
+              </a:spcAft>
+            </a:pPr>
+            <a:r>
+              <a:rPr sz="1300">
+                <a:solidFill>
+                  <a:srgbClr val="3D5466"/>
+                </a:solidFill>
+                <a:latin typeface="Arial"/>
+              </a:rPr>
+              <a:t>▸  Pflege Musterregion GmbH: befristete Bürgschaft, Nachweis fehlt, Frist in 3 Wochen.</a:t>
+            </a:r>
+          </a:p>
+          <a:p>
+            <a:pPr marL="190500" indent="-190500">
+              <a:spcBef>
+                <a:spcPts val="400"/>
+              </a:spcBef>
+              <a:spcAft>
+                <a:spcPts val="200"/>
+              </a:spcAft>
+            </a:pPr>
+            <a:r>
+              <a:rPr sz="1300">
+                <a:solidFill>
+                  <a:srgbClr val="3D5466"/>
+                </a:solidFill>
+                <a:latin typeface="Arial"/>
+              </a:rPr>
+              <a:t>▸  Technik Musterregion GmbH: Adresse veraltet (Post kommt zurück), kein Ansprechpartner.</a:t>
+            </a:r>
+          </a:p>
+        </p:txBody>
+      </p:sp>
+      <p:sp>
+        <p:nvSpPr>
+          <p:cNvPr id="9" name="Rectangle 8"/>
+          <p:cNvSpPr/>
+          <p:nvPr/>
+        </p:nvSpPr>
+        <p:spPr>
+          <a:xfrm>
+            <a:off x="0" y="6510528"/>
+            <a:ext cx="12188952" cy="347472"/>
+          </a:xfrm>
+          <a:prstGeom prst="rect">
+            <a:avLst/>
+          </a:prstGeom>
+          <a:solidFill>
+            <a:srgbClr val="0A1937"/>
+          </a:solidFill>
+          <a:ln>
+            <a:noFill/>
+          </a:ln>
+        </p:spPr>
+        <p:style>
+          <a:lnRef idx="1">
+            <a:schemeClr val="accent1"/>
+          </a:lnRef>
+          <a:fillRef idx="3">
+            <a:schemeClr val="accent1"/>
+          </a:fillRef>
+          <a:effectRef idx="2">
+            <a:schemeClr val="accent1"/>
+          </a:effectRef>
+          <a:fontRef idx="minor">
+            <a:schemeClr val="lt1"/>
+          </a:fontRef>
+        </p:style>
+        <p:txBody>
+          <a:bodyPr rtlCol="0" anchor="ctr"/>
+          <a:lstStyle/>
+          <a:p>
+            <a:pPr algn="ctr"/>
+          </a:p>
+        </p:txBody>
+      </p:sp>
+      <p:sp>
+        <p:nvSpPr>
+          <p:cNvPr id="10" name="TextBox 9"/>
+          <p:cNvSpPr txBox="1"/>
+          <p:nvPr/>
+        </p:nvSpPr>
+        <p:spPr>
+          <a:xfrm>
+            <a:off x="685800" y="6583680"/>
+            <a:ext cx="6490411" cy="256032"/>
+          </a:xfrm>
+          <a:prstGeom prst="rect">
+            <a:avLst/>
+          </a:prstGeom>
+          <a:noFill/>
+        </p:spPr>
+        <p:txBody>
+          <a:bodyPr wrap="none">
+            <a:spAutoFit/>
+          </a:bodyPr>
+          <a:lstStyle/>
+          <a:p>
+            <a:pPr algn="l"/>
+            <a:r>
+              <a:rPr sz="700">
+                <a:solidFill>
+                  <a:srgbClr val="A0B4D2"/>
+                </a:solidFill>
+                <a:latin typeface="Consolas"/>
+              </a:rPr>
+              <a:t>FKB Campus  ·  VA04</a:t>
+            </a:r>
+          </a:p>
+        </p:txBody>
+      </p:sp>
+    </p:spTree>
+  </p:cSld>
+  <p:clrMapOvr>
+    <a:masterClrMapping/>
+  </p:clrMapOvr>
+</p:sld>
+</file>
+
+<file path=ppt/slides/slide13.xml><?xml version="1.0" encoding="utf-8"?>
+<p:sld xmlns:a="http://schemas.openxmlformats.org/drawingml/2006/main" xmlns:p="http://schemas.openxmlformats.org/presentationml/2006/main" xmlns:r="http://schemas.openxmlformats.org/officeDocument/2006/relationships">
+  <p:cSld>
+    <p:spTree>
+      <p:nvGrpSpPr>
+        <p:cNvPr id="1" name=""/>
+        <p:cNvGrpSpPr/>
+        <p:nvPr/>
+      </p:nvGrpSpPr>
+      <p:grpSpPr/>
+      <p:sp>
+        <p:nvSpPr>
+          <p:cNvPr id="2" name="Rectangle 1"/>
+          <p:cNvSpPr/>
+          <p:nvPr/>
+        </p:nvSpPr>
+        <p:spPr>
+          <a:xfrm>
+            <a:off x="0" y="0"/>
+            <a:ext cx="12188952" cy="6858000"/>
+          </a:xfrm>
+          <a:prstGeom prst="rect">
+            <a:avLst/>
+          </a:prstGeom>
+          <a:solidFill>
+            <a:srgbClr val="EDEDF3"/>
+          </a:solidFill>
+          <a:ln>
+            <a:noFill/>
+          </a:ln>
+        </p:spPr>
+        <p:style>
+          <a:lnRef idx="1">
+            <a:schemeClr val="accent1"/>
+          </a:lnRef>
+          <a:fillRef idx="3">
+            <a:schemeClr val="accent1"/>
+          </a:fillRef>
+          <a:effectRef idx="2">
+            <a:schemeClr val="accent1"/>
+          </a:effectRef>
+          <a:fontRef idx="minor">
+            <a:schemeClr val="lt1"/>
+          </a:fontRef>
+        </p:style>
+        <p:txBody>
+          <a:bodyPr rtlCol="0" anchor="ctr"/>
+          <a:lstStyle/>
+          <a:p>
+            <a:pPr algn="ctr"/>
+          </a:p>
+        </p:txBody>
+      </p:sp>
+      <p:sp>
+        <p:nvSpPr>
+          <p:cNvPr id="3" name="Rectangle 2"/>
+          <p:cNvSpPr/>
+          <p:nvPr/>
+        </p:nvSpPr>
+        <p:spPr>
+          <a:xfrm>
+            <a:off x="0" y="0"/>
+            <a:ext cx="12188952" cy="50292"/>
+          </a:xfrm>
+          <a:prstGeom prst="rect">
+            <a:avLst/>
+          </a:prstGeom>
+          <a:solidFill>
+            <a:srgbClr val="1F2C56"/>
+          </a:solidFill>
+          <a:ln>
+            <a:noFill/>
+          </a:ln>
+        </p:spPr>
+        <p:style>
+          <a:lnRef idx="1">
+            <a:schemeClr val="accent1"/>
+          </a:lnRef>
+          <a:fillRef idx="3">
+            <a:schemeClr val="accent1"/>
+          </a:fillRef>
+          <a:effectRef idx="2">
+            <a:schemeClr val="accent1"/>
+          </a:effectRef>
+          <a:fontRef idx="minor">
+            <a:schemeClr val="lt1"/>
+          </a:fontRef>
+        </p:style>
+        <p:txBody>
+          <a:bodyPr rtlCol="0" anchor="ctr"/>
+          <a:lstStyle/>
+          <a:p>
+            <a:pPr algn="ctr"/>
+          </a:p>
+        </p:txBody>
+      </p:sp>
+      <p:sp>
+        <p:nvSpPr>
+          <p:cNvPr id="4" name="TextBox 3"/>
+          <p:cNvSpPr txBox="1"/>
+          <p:nvPr/>
+        </p:nvSpPr>
+        <p:spPr>
+          <a:xfrm>
+            <a:off x="685800" y="109728"/>
+            <a:ext cx="10817352" cy="228600"/>
+          </a:xfrm>
+          <a:prstGeom prst="rect">
+            <a:avLst/>
+          </a:prstGeom>
+          <a:noFill/>
+        </p:spPr>
+        <p:txBody>
+          <a:bodyPr wrap="none">
+            <a:spAutoFit/>
+          </a:bodyPr>
+          <a:lstStyle/>
+          <a:p>
+            <a:pPr algn="l"/>
+            <a:r>
+              <a:rPr sz="750">
+                <a:solidFill>
+                  <a:srgbClr val="78808C"/>
+                </a:solidFill>
+                <a:latin typeface="Consolas"/>
+              </a:rPr>
+              <a:t>VA04  ·  INHALT</a:t>
+            </a:r>
+          </a:p>
+        </p:txBody>
+      </p:sp>
+      <p:sp>
+        <p:nvSpPr>
+          <p:cNvPr id="5" name="Rectangle 4"/>
+          <p:cNvSpPr/>
+          <p:nvPr/>
+        </p:nvSpPr>
+        <p:spPr>
+          <a:xfrm>
+            <a:off x="0" y="1234440"/>
+            <a:ext cx="12188952" cy="12700"/>
+          </a:xfrm>
+          <a:prstGeom prst="rect">
+            <a:avLst/>
+          </a:prstGeom>
+          <a:solidFill>
+            <a:srgbClr val="D8DFE4"/>
+          </a:solidFill>
+          <a:ln>
+            <a:noFill/>
+          </a:ln>
+        </p:spPr>
+        <p:style>
+          <a:lnRef idx="1">
+            <a:schemeClr val="accent1"/>
+          </a:lnRef>
+          <a:fillRef idx="3">
+            <a:schemeClr val="accent1"/>
+          </a:fillRef>
+          <a:effectRef idx="2">
+            <a:schemeClr val="accent1"/>
+          </a:effectRef>
+          <a:fontRef idx="minor">
+            <a:schemeClr val="lt1"/>
+          </a:fontRef>
+        </p:style>
+        <p:txBody>
+          <a:bodyPr rtlCol="0" anchor="ctr"/>
+          <a:lstStyle/>
+          <a:p>
+            <a:pPr algn="ctr"/>
+          </a:p>
+        </p:txBody>
+      </p:sp>
+      <p:sp>
+        <p:nvSpPr>
+          <p:cNvPr id="6" name="Rectangle 5"/>
+          <p:cNvSpPr/>
+          <p:nvPr/>
+        </p:nvSpPr>
+        <p:spPr>
+          <a:xfrm>
+            <a:off x="685800" y="502920"/>
+            <a:ext cx="36576" cy="658368"/>
+          </a:xfrm>
+          <a:prstGeom prst="rect">
+            <a:avLst/>
+          </a:prstGeom>
+          <a:solidFill>
+            <a:srgbClr val="D9C089"/>
+          </a:solidFill>
+          <a:ln>
+            <a:noFill/>
+          </a:ln>
+        </p:spPr>
+        <p:style>
+          <a:lnRef idx="1">
+            <a:schemeClr val="accent1"/>
+          </a:lnRef>
+          <a:fillRef idx="3">
+            <a:schemeClr val="accent1"/>
+          </a:fillRef>
+          <a:effectRef idx="2">
+            <a:schemeClr val="accent1"/>
+          </a:effectRef>
+          <a:fontRef idx="minor">
+            <a:schemeClr val="lt1"/>
+          </a:fontRef>
+        </p:style>
+        <p:txBody>
+          <a:bodyPr rtlCol="0" anchor="ctr"/>
+          <a:lstStyle/>
+          <a:p>
+            <a:pPr algn="ctr"/>
+          </a:p>
+        </p:txBody>
+      </p:sp>
+      <p:sp>
+        <p:nvSpPr>
+          <p:cNvPr id="7" name="TextBox 6"/>
+          <p:cNvSpPr txBox="1"/>
+          <p:nvPr/>
+        </p:nvSpPr>
+        <p:spPr>
+          <a:xfrm>
+            <a:off x="813816" y="502920"/>
+            <a:ext cx="10634472" cy="685800"/>
+          </a:xfrm>
+          <a:prstGeom prst="rect">
+            <a:avLst/>
+          </a:prstGeom>
+          <a:noFill/>
+        </p:spPr>
+        <p:txBody>
+          <a:bodyPr wrap="square">
+            <a:spAutoFit/>
+          </a:bodyPr>
+          <a:lstStyle/>
+          <a:p>
+            <a:pPr algn="l"/>
+            <a:r>
+              <a:rPr sz="2400" b="1" i="0">
+                <a:solidFill>
+                  <a:srgbClr val="1F2C56"/>
+                </a:solidFill>
+                <a:latin typeface="Arial"/>
+              </a:rPr>
+              <a:t>Handlungsempfehlung: Befund zu Frist zu Anlass</a:t>
+            </a:r>
+          </a:p>
+        </p:txBody>
+      </p:sp>
+      <p:sp>
+        <p:nvSpPr>
+          <p:cNvPr id="8" name="TextBox 7"/>
+          <p:cNvSpPr txBox="1"/>
+          <p:nvPr/>
+        </p:nvSpPr>
+        <p:spPr>
+          <a:xfrm>
+            <a:off x="685800" y="1417320"/>
+            <a:ext cx="10817352" cy="4892040"/>
+          </a:xfrm>
+          <a:prstGeom prst="rect">
+            <a:avLst/>
+          </a:prstGeom>
+          <a:noFill/>
+        </p:spPr>
+        <p:txBody>
+          <a:bodyPr wrap="square" anchor="ctr">
+            <a:spAutoFit/>
+          </a:bodyPr>
+          <a:lstStyle/>
+          <a:p>
+            <a:pPr marL="177800" indent="-177800">
+              <a:spcBef>
+                <a:spcPts val="600"/>
+              </a:spcBef>
+              <a:spcAft>
+                <a:spcPts val="200"/>
+              </a:spcAft>
+            </a:pPr>
+            <a:r>
+              <a:rPr sz="1200" i="1">
+                <a:solidFill>
+                  <a:srgbClr val="3D5466"/>
+                </a:solidFill>
+                <a:latin typeface="Arial"/>
+              </a:rPr>
+              <a:t>→  Wenn eine § 18-Offenlegung überfällig ist — dann sofort nachfordern, Wiedervorlage setzen und die Marktfolge informieren (Priorität 1).</a:t>
+            </a:r>
+          </a:p>
+          <a:p>
+            <a:pPr marL="177800" indent="-177800">
+              <a:spcBef>
+                <a:spcPts val="600"/>
+              </a:spcBef>
+              <a:spcAft>
+                <a:spcPts val="200"/>
+              </a:spcAft>
+            </a:pPr>
+            <a:r>
+              <a:rPr sz="1200" i="1">
+                <a:solidFill>
+                  <a:srgbClr val="3D5466"/>
+                </a:solidFill>
+                <a:latin typeface="Arial"/>
+              </a:rPr>
+              <a:t>→  Wenn eine Zinsbindung oder Befristung ausläuft — dann rechtzeitig Wiedervorlage anlegen und den Berater als Vertriebsanlass informieren.</a:t>
+            </a:r>
+          </a:p>
+          <a:p>
+            <a:pPr marL="177800" indent="-177800">
+              <a:spcBef>
+                <a:spcPts val="600"/>
+              </a:spcBef>
+              <a:spcAft>
+                <a:spcPts val="200"/>
+              </a:spcAft>
+            </a:pPr>
+            <a:r>
+              <a:rPr sz="1200" i="1">
+                <a:solidFill>
+                  <a:srgbClr val="3D5466"/>
+                </a:solidFill>
+                <a:latin typeface="Arial"/>
+              </a:rPr>
+              <a:t>→  Wenn Post als Rückläufer kommt — dann Adresse über den erlaubten Weg korrigieren und die Quelle der Änderung dokumentieren.</a:t>
+            </a:r>
+          </a:p>
+        </p:txBody>
+      </p:sp>
+      <p:sp>
+        <p:nvSpPr>
+          <p:cNvPr id="9" name="Rectangle 8"/>
+          <p:cNvSpPr/>
+          <p:nvPr/>
+        </p:nvSpPr>
+        <p:spPr>
+          <a:xfrm>
+            <a:off x="0" y="6510528"/>
+            <a:ext cx="12188952" cy="347472"/>
+          </a:xfrm>
+          <a:prstGeom prst="rect">
+            <a:avLst/>
+          </a:prstGeom>
+          <a:solidFill>
+            <a:srgbClr val="0A1937"/>
+          </a:solidFill>
+          <a:ln>
+            <a:noFill/>
+          </a:ln>
+        </p:spPr>
+        <p:style>
+          <a:lnRef idx="1">
+            <a:schemeClr val="accent1"/>
+          </a:lnRef>
+          <a:fillRef idx="3">
+            <a:schemeClr val="accent1"/>
+          </a:fillRef>
+          <a:effectRef idx="2">
+            <a:schemeClr val="accent1"/>
+          </a:effectRef>
+          <a:fontRef idx="minor">
+            <a:schemeClr val="lt1"/>
+          </a:fontRef>
+        </p:style>
+        <p:txBody>
+          <a:bodyPr rtlCol="0" anchor="ctr"/>
+          <a:lstStyle/>
+          <a:p>
+            <a:pPr algn="ctr"/>
+          </a:p>
+        </p:txBody>
+      </p:sp>
+      <p:sp>
+        <p:nvSpPr>
+          <p:cNvPr id="10" name="TextBox 9"/>
+          <p:cNvSpPr txBox="1"/>
+          <p:nvPr/>
+        </p:nvSpPr>
+        <p:spPr>
+          <a:xfrm>
+            <a:off x="685800" y="6583680"/>
+            <a:ext cx="6490411" cy="256032"/>
+          </a:xfrm>
+          <a:prstGeom prst="rect">
+            <a:avLst/>
+          </a:prstGeom>
+          <a:noFill/>
+        </p:spPr>
+        <p:txBody>
+          <a:bodyPr wrap="none">
+            <a:spAutoFit/>
+          </a:bodyPr>
+          <a:lstStyle/>
+          <a:p>
+            <a:pPr algn="l"/>
+            <a:r>
+              <a:rPr sz="700">
+                <a:solidFill>
+                  <a:srgbClr val="A0B4D2"/>
+                </a:solidFill>
+                <a:latin typeface="Consolas"/>
+              </a:rPr>
+              <a:t>FKB Campus  ·  VA04</a:t>
+            </a:r>
+          </a:p>
+        </p:txBody>
+      </p:sp>
+    </p:spTree>
+  </p:cSld>
+  <p:clrMapOvr>
+    <a:masterClrMapping/>
+  </p:clrMapOvr>
+</p:sld>
+</file>
+
+<file path=ppt/slides/slide14.xml><?xml version="1.0" encoding="utf-8"?>
+<p:sld xmlns:a="http://schemas.openxmlformats.org/drawingml/2006/main" xmlns:p="http://schemas.openxmlformats.org/presentationml/2006/main" xmlns:r="http://schemas.openxmlformats.org/officeDocument/2006/relationships">
+  <p:cSld>
+    <p:spTree>
+      <p:nvGrpSpPr>
+        <p:cNvPr id="1" name=""/>
+        <p:cNvGrpSpPr/>
+        <p:nvPr/>
+      </p:nvGrpSpPr>
+      <p:grpSpPr/>
+      <p:sp>
+        <p:nvSpPr>
+          <p:cNvPr id="2" name="Rectangle 1"/>
+          <p:cNvSpPr/>
+          <p:nvPr/>
+        </p:nvSpPr>
+        <p:spPr>
+          <a:xfrm>
+            <a:off x="0" y="0"/>
+            <a:ext cx="12188952" cy="6858000"/>
+          </a:xfrm>
+          <a:prstGeom prst="rect">
+            <a:avLst/>
+          </a:prstGeom>
+          <a:solidFill>
+            <a:srgbClr val="EDEDF3"/>
+          </a:solidFill>
+          <a:ln>
+            <a:noFill/>
+          </a:ln>
+        </p:spPr>
+        <p:style>
+          <a:lnRef idx="1">
+            <a:schemeClr val="accent1"/>
+          </a:lnRef>
+          <a:fillRef idx="3">
+            <a:schemeClr val="accent1"/>
+          </a:fillRef>
+          <a:effectRef idx="2">
+            <a:schemeClr val="accent1"/>
+          </a:effectRef>
+          <a:fontRef idx="minor">
+            <a:schemeClr val="lt1"/>
+          </a:fontRef>
+        </p:style>
+        <p:txBody>
+          <a:bodyPr rtlCol="0" anchor="ctr"/>
+          <a:lstStyle/>
+          <a:p>
+            <a:pPr algn="ctr"/>
+          </a:p>
+        </p:txBody>
+      </p:sp>
+      <p:sp>
+        <p:nvSpPr>
+          <p:cNvPr id="3" name="Rectangle 2"/>
+          <p:cNvSpPr/>
+          <p:nvPr/>
+        </p:nvSpPr>
+        <p:spPr>
+          <a:xfrm>
+            <a:off x="0" y="0"/>
+            <a:ext cx="12188952" cy="50292"/>
+          </a:xfrm>
+          <a:prstGeom prst="rect">
+            <a:avLst/>
+          </a:prstGeom>
+          <a:solidFill>
+            <a:srgbClr val="1F2C56"/>
+          </a:solidFill>
+          <a:ln>
+            <a:noFill/>
+          </a:ln>
+        </p:spPr>
+        <p:style>
+          <a:lnRef idx="1">
+            <a:schemeClr val="accent1"/>
+          </a:lnRef>
+          <a:fillRef idx="3">
+            <a:schemeClr val="accent1"/>
+          </a:fillRef>
+          <a:effectRef idx="2">
+            <a:schemeClr val="accent1"/>
+          </a:effectRef>
+          <a:fontRef idx="minor">
+            <a:schemeClr val="lt1"/>
+          </a:fontRef>
+        </p:style>
+        <p:txBody>
+          <a:bodyPr rtlCol="0" anchor="ctr"/>
+          <a:lstStyle/>
+          <a:p>
+            <a:pPr algn="ctr"/>
+          </a:p>
+        </p:txBody>
+      </p:sp>
+      <p:sp>
+        <p:nvSpPr>
+          <p:cNvPr id="4" name="TextBox 3"/>
+          <p:cNvSpPr txBox="1"/>
+          <p:nvPr/>
+        </p:nvSpPr>
+        <p:spPr>
+          <a:xfrm>
+            <a:off x="685800" y="109728"/>
+            <a:ext cx="10817352" cy="228600"/>
+          </a:xfrm>
+          <a:prstGeom prst="rect">
+            <a:avLst/>
+          </a:prstGeom>
+          <a:noFill/>
+        </p:spPr>
+        <p:txBody>
+          <a:bodyPr wrap="none">
+            <a:spAutoFit/>
+          </a:bodyPr>
+          <a:lstStyle/>
+          <a:p>
+            <a:pPr algn="l"/>
+            <a:r>
+              <a:rPr sz="750">
+                <a:solidFill>
+                  <a:srgbClr val="78808C"/>
+                </a:solidFill>
+                <a:latin typeface="Consolas"/>
+              </a:rPr>
+              <a:t>VA04  ·  ARBEITSBLATT</a:t>
+            </a:r>
+          </a:p>
+        </p:txBody>
+      </p:sp>
+      <p:sp>
+        <p:nvSpPr>
+          <p:cNvPr id="5" name="Rectangle 4"/>
+          <p:cNvSpPr/>
+          <p:nvPr/>
+        </p:nvSpPr>
+        <p:spPr>
+          <a:xfrm>
+            <a:off x="0" y="1234440"/>
+            <a:ext cx="12188952" cy="12700"/>
+          </a:xfrm>
+          <a:prstGeom prst="rect">
+            <a:avLst/>
+          </a:prstGeom>
+          <a:solidFill>
+            <a:srgbClr val="D8DFE4"/>
+          </a:solidFill>
+          <a:ln>
+            <a:noFill/>
+          </a:ln>
+        </p:spPr>
+        <p:style>
+          <a:lnRef idx="1">
+            <a:schemeClr val="accent1"/>
+          </a:lnRef>
+          <a:fillRef idx="3">
+            <a:schemeClr val="accent1"/>
+          </a:fillRef>
+          <a:effectRef idx="2">
+            <a:schemeClr val="accent1"/>
+          </a:effectRef>
+          <a:fontRef idx="minor">
+            <a:schemeClr val="lt1"/>
+          </a:fontRef>
+        </p:style>
+        <p:txBody>
+          <a:bodyPr rtlCol="0" anchor="ctr"/>
+          <a:lstStyle/>
+          <a:p>
+            <a:pPr algn="ctr"/>
+          </a:p>
+        </p:txBody>
+      </p:sp>
+      <p:sp>
+        <p:nvSpPr>
+          <p:cNvPr id="6" name="Rectangle 5"/>
+          <p:cNvSpPr/>
+          <p:nvPr/>
+        </p:nvSpPr>
+        <p:spPr>
+          <a:xfrm>
+            <a:off x="685800" y="502920"/>
+            <a:ext cx="36576" cy="658368"/>
+          </a:xfrm>
+          <a:prstGeom prst="rect">
+            <a:avLst/>
+          </a:prstGeom>
+          <a:solidFill>
+            <a:srgbClr val="D9C089"/>
+          </a:solidFill>
+          <a:ln>
+            <a:noFill/>
+          </a:ln>
+        </p:spPr>
+        <p:style>
+          <a:lnRef idx="1">
+            <a:schemeClr val="accent1"/>
+          </a:lnRef>
+          <a:fillRef idx="3">
+            <a:schemeClr val="accent1"/>
+          </a:fillRef>
+          <a:effectRef idx="2">
+            <a:schemeClr val="accent1"/>
+          </a:effectRef>
+          <a:fontRef idx="minor">
+            <a:schemeClr val="lt1"/>
+          </a:fontRef>
+        </p:style>
+        <p:txBody>
+          <a:bodyPr rtlCol="0" anchor="ctr"/>
+          <a:lstStyle/>
+          <a:p>
+            <a:pPr algn="ctr"/>
+          </a:p>
+        </p:txBody>
+      </p:sp>
+      <p:sp>
+        <p:nvSpPr>
+          <p:cNvPr id="7" name="TextBox 6"/>
+          <p:cNvSpPr txBox="1"/>
+          <p:nvPr/>
+        </p:nvSpPr>
+        <p:spPr>
+          <a:xfrm>
+            <a:off x="813816" y="502920"/>
+            <a:ext cx="10634472" cy="685800"/>
+          </a:xfrm>
+          <a:prstGeom prst="rect">
+            <a:avLst/>
+          </a:prstGeom>
+          <a:noFill/>
+        </p:spPr>
+        <p:txBody>
+          <a:bodyPr wrap="square">
+            <a:spAutoFit/>
+          </a:bodyPr>
+          <a:lstStyle/>
+          <a:p>
+            <a:pPr algn="l"/>
+            <a:r>
+              <a:rPr sz="2400" b="1" i="0">
+                <a:solidFill>
+                  <a:srgbClr val="1F2C56"/>
+                </a:solidFill>
+                <a:latin typeface="Arial"/>
+              </a:rPr>
+              <a:t>Praxisfall bearbeiten: priorisieren und steuern</a:t>
+            </a:r>
+          </a:p>
+        </p:txBody>
+      </p:sp>
+      <p:sp>
+        <p:nvSpPr>
+          <p:cNvPr id="8" name="TextBox 7"/>
+          <p:cNvSpPr txBox="1"/>
+          <p:nvPr/>
+        </p:nvSpPr>
+        <p:spPr>
+          <a:xfrm>
+            <a:off x="685800" y="1554480"/>
+            <a:ext cx="10817352" cy="3840480"/>
+          </a:xfrm>
+          <a:prstGeom prst="rect">
+            <a:avLst/>
+          </a:prstGeom>
+          <a:noFill/>
+        </p:spPr>
+        <p:txBody>
+          <a:bodyPr wrap="square">
+            <a:spAutoFit/>
+          </a:bodyPr>
+          <a:lstStyle/>
+          <a:p>
+            <a:pPr marL="190500" indent="-190500">
+              <a:spcBef>
+                <a:spcPts val="400"/>
+              </a:spcBef>
+              <a:spcAft>
+                <a:spcPts val="200"/>
+              </a:spcAft>
+            </a:pPr>
+            <a:r>
+              <a:rPr sz="1400">
+                <a:solidFill>
+                  <a:srgbClr val="3D5466"/>
+                </a:solidFill>
+                <a:latin typeface="Arial"/>
+              </a:rPr>
+              <a:t>▸  Bringen Sie die vier Befunde in eine begründete Prioritätenreihenfolge (AB-1).</a:t>
+            </a:r>
+          </a:p>
+          <a:p>
+            <a:pPr marL="190500" indent="-190500">
+              <a:spcBef>
+                <a:spcPts val="400"/>
+              </a:spcBef>
+              <a:spcAft>
+                <a:spcPts val="200"/>
+              </a:spcAft>
+            </a:pPr>
+            <a:r>
+              <a:rPr sz="1400">
+                <a:solidFill>
+                  <a:srgbClr val="3D5466"/>
+                </a:solidFill>
+                <a:latin typeface="Arial"/>
+              </a:rPr>
+              <a:t>▸  Legen Sie für jeden Befund eine Wiedervorlage mit Frist und Verantwortlichem an (AB-2).</a:t>
+            </a:r>
+          </a:p>
+          <a:p>
+            <a:pPr marL="190500" indent="-190500">
+              <a:spcBef>
+                <a:spcPts val="400"/>
+              </a:spcBef>
+              <a:spcAft>
+                <a:spcPts val="200"/>
+              </a:spcAft>
+            </a:pPr>
+            <a:r>
+              <a:rPr sz="1400">
+                <a:solidFill>
+                  <a:srgbClr val="3D5466"/>
+                </a:solidFill>
+                <a:latin typeface="Arial"/>
+              </a:rPr>
+              <a:t>▸  Bereinigen Sie die Stammdaten der Technik Musterregion rechtssicher (AB-3).</a:t>
+            </a:r>
+          </a:p>
+          <a:p>
+            <a:pPr marL="190500" indent="-190500">
+              <a:spcBef>
+                <a:spcPts val="400"/>
+              </a:spcBef>
+              <a:spcAft>
+                <a:spcPts val="200"/>
+              </a:spcAft>
+            </a:pPr>
+            <a:r>
+              <a:rPr sz="1400">
+                <a:solidFill>
+                  <a:srgbClr val="3D5466"/>
+                </a:solidFill>
+                <a:latin typeface="Arial"/>
+              </a:rPr>
+              <a:t>▸  Entwerfen Sie Ihren eigenen Prozess: was täglich / wöchentlich / monatlich? (AB-4) – Karte AB-5 als Werkzeug.</a:t>
+            </a:r>
+          </a:p>
+        </p:txBody>
+      </p:sp>
+      <p:sp>
+        <p:nvSpPr>
+          <p:cNvPr id="9" name="Rectangle 8"/>
+          <p:cNvSpPr/>
+          <p:nvPr/>
+        </p:nvSpPr>
+        <p:spPr>
+          <a:xfrm>
+            <a:off x="685800" y="5486400"/>
+            <a:ext cx="10817352" cy="640080"/>
+          </a:xfrm>
+          <a:prstGeom prst="rect">
+            <a:avLst/>
+          </a:prstGeom>
+          <a:solidFill>
+            <a:srgbClr val="1F2C56"/>
+          </a:solidFill>
+          <a:ln>
+            <a:noFill/>
+          </a:ln>
+        </p:spPr>
+        <p:style>
+          <a:lnRef idx="1">
+            <a:schemeClr val="accent1"/>
+          </a:lnRef>
+          <a:fillRef idx="3">
+            <a:schemeClr val="accent1"/>
+          </a:fillRef>
+          <a:effectRef idx="2">
+            <a:schemeClr val="accent1"/>
+          </a:effectRef>
+          <a:fontRef idx="minor">
+            <a:schemeClr val="lt1"/>
+          </a:fontRef>
+        </p:style>
+        <p:txBody>
+          <a:bodyPr rtlCol="0" anchor="ctr"/>
+          <a:lstStyle/>
+          <a:p>
+            <a:pPr algn="ctr"/>
+          </a:p>
+        </p:txBody>
+      </p:sp>
+      <p:sp>
+        <p:nvSpPr>
+          <p:cNvPr id="10" name="TextBox 9"/>
+          <p:cNvSpPr txBox="1"/>
+          <p:nvPr/>
+        </p:nvSpPr>
+        <p:spPr>
+          <a:xfrm>
+            <a:off x="868680" y="5596128"/>
+            <a:ext cx="10451592" cy="457200"/>
+          </a:xfrm>
+          <a:prstGeom prst="rect">
+            <a:avLst/>
+          </a:prstGeom>
+          <a:noFill/>
+        </p:spPr>
+        <p:txBody>
+          <a:bodyPr wrap="square">
+            <a:spAutoFit/>
+          </a:bodyPr>
+          <a:lstStyle/>
+          <a:p>
+            <a:pPr algn="l"/>
+            <a:r>
+              <a:rPr sz="1300" b="1" i="0">
+                <a:solidFill>
+                  <a:srgbClr val="FFFFFF"/>
+                </a:solidFill>
+                <a:latin typeface="Arial"/>
+              </a:rPr>
+              <a:t>→  Bearbeitung im Teilnehmer-Workbook (Arbeitsblatt mit Ausfüllfeldern)</a:t>
+            </a:r>
+          </a:p>
+        </p:txBody>
+      </p:sp>
+      <p:sp>
+        <p:nvSpPr>
+          <p:cNvPr id="11" name="Rectangle 10"/>
+          <p:cNvSpPr/>
+          <p:nvPr/>
+        </p:nvSpPr>
+        <p:spPr>
+          <a:xfrm>
+            <a:off x="0" y="6510528"/>
+            <a:ext cx="12188952" cy="347472"/>
+          </a:xfrm>
+          <a:prstGeom prst="rect">
+            <a:avLst/>
+          </a:prstGeom>
+          <a:solidFill>
+            <a:srgbClr val="0A1937"/>
+          </a:solidFill>
+          <a:ln>
+            <a:noFill/>
+          </a:ln>
+        </p:spPr>
+        <p:style>
+          <a:lnRef idx="1">
+            <a:schemeClr val="accent1"/>
+          </a:lnRef>
+          <a:fillRef idx="3">
+            <a:schemeClr val="accent1"/>
+          </a:fillRef>
+          <a:effectRef idx="2">
+            <a:schemeClr val="accent1"/>
+          </a:effectRef>
+          <a:fontRef idx="minor">
+            <a:schemeClr val="lt1"/>
+          </a:fontRef>
+        </p:style>
+        <p:txBody>
+          <a:bodyPr rtlCol="0" anchor="ctr"/>
+          <a:lstStyle/>
+          <a:p>
+            <a:pPr algn="ctr"/>
+          </a:p>
+        </p:txBody>
+      </p:sp>
+      <p:sp>
+        <p:nvSpPr>
+          <p:cNvPr id="12" name="TextBox 11"/>
+          <p:cNvSpPr txBox="1"/>
+          <p:nvPr/>
+        </p:nvSpPr>
+        <p:spPr>
+          <a:xfrm>
+            <a:off x="685800" y="6583680"/>
+            <a:ext cx="6490411" cy="256032"/>
+          </a:xfrm>
+          <a:prstGeom prst="rect">
+            <a:avLst/>
+          </a:prstGeom>
+          <a:noFill/>
+        </p:spPr>
+        <p:txBody>
+          <a:bodyPr wrap="none">
+            <a:spAutoFit/>
+          </a:bodyPr>
+          <a:lstStyle/>
+          <a:p>
+            <a:pPr algn="l"/>
+            <a:r>
+              <a:rPr sz="700">
+                <a:solidFill>
+                  <a:srgbClr val="A0B4D2"/>
+                </a:solidFill>
+                <a:latin typeface="Consolas"/>
+              </a:rPr>
+              <a:t>FKB Campus  ·  VA04</a:t>
+            </a:r>
+          </a:p>
+        </p:txBody>
+      </p:sp>
+    </p:spTree>
+  </p:cSld>
+  <p:clrMapOvr>
+    <a:masterClrMapping/>
+  </p:clrMapOvr>
+</p:sld>
+</file>
+
+<file path=ppt/slides/slide15.xml><?xml version="1.0" encoding="utf-8"?>
+<p:sld xmlns:a="http://schemas.openxmlformats.org/drawingml/2006/main" xmlns:p="http://schemas.openxmlformats.org/presentationml/2006/main" xmlns:r="http://schemas.openxmlformats.org/officeDocument/2006/relationships">
+  <p:cSld>
+    <p:spTree>
+      <p:nvGrpSpPr>
+        <p:cNvPr id="1" name=""/>
+        <p:cNvGrpSpPr/>
+        <p:nvPr/>
+      </p:nvGrpSpPr>
+      <p:grpSpPr/>
+      <p:sp>
+        <p:nvSpPr>
+          <p:cNvPr id="2" name="Rectangle 1"/>
+          <p:cNvSpPr/>
+          <p:nvPr/>
+        </p:nvSpPr>
+        <p:spPr>
+          <a:xfrm>
+            <a:off x="0" y="0"/>
+            <a:ext cx="12188952" cy="6858000"/>
+          </a:xfrm>
+          <a:prstGeom prst="rect">
+            <a:avLst/>
+          </a:prstGeom>
+          <a:solidFill>
+            <a:srgbClr val="EDEDF3"/>
+          </a:solidFill>
+          <a:ln>
+            <a:noFill/>
+          </a:ln>
+        </p:spPr>
+        <p:style>
+          <a:lnRef idx="1">
+            <a:schemeClr val="accent1"/>
+          </a:lnRef>
+          <a:fillRef idx="3">
+            <a:schemeClr val="accent1"/>
+          </a:fillRef>
+          <a:effectRef idx="2">
+            <a:schemeClr val="accent1"/>
+          </a:effectRef>
+          <a:fontRef idx="minor">
+            <a:schemeClr val="lt1"/>
+          </a:fontRef>
+        </p:style>
+        <p:txBody>
+          <a:bodyPr rtlCol="0" anchor="ctr"/>
+          <a:lstStyle/>
+          <a:p>
+            <a:pPr algn="ctr"/>
+          </a:p>
+        </p:txBody>
+      </p:sp>
+      <p:sp>
+        <p:nvSpPr>
+          <p:cNvPr id="3" name="Rectangle 2"/>
+          <p:cNvSpPr/>
+          <p:nvPr/>
+        </p:nvSpPr>
+        <p:spPr>
+          <a:xfrm>
+            <a:off x="0" y="0"/>
+            <a:ext cx="12188952" cy="50292"/>
+          </a:xfrm>
+          <a:prstGeom prst="rect">
+            <a:avLst/>
+          </a:prstGeom>
+          <a:solidFill>
+            <a:srgbClr val="1F2C56"/>
+          </a:solidFill>
+          <a:ln>
+            <a:noFill/>
+          </a:ln>
+        </p:spPr>
+        <p:style>
+          <a:lnRef idx="1">
+            <a:schemeClr val="accent1"/>
+          </a:lnRef>
+          <a:fillRef idx="3">
+            <a:schemeClr val="accent1"/>
+          </a:fillRef>
+          <a:effectRef idx="2">
+            <a:schemeClr val="accent1"/>
+          </a:effectRef>
+          <a:fontRef idx="minor">
+            <a:schemeClr val="lt1"/>
+          </a:fontRef>
+        </p:style>
+        <p:txBody>
+          <a:bodyPr rtlCol="0" anchor="ctr"/>
+          <a:lstStyle/>
+          <a:p>
+            <a:pPr algn="ctr"/>
+          </a:p>
+        </p:txBody>
+      </p:sp>
+      <p:sp>
+        <p:nvSpPr>
+          <p:cNvPr id="4" name="TextBox 3"/>
+          <p:cNvSpPr txBox="1"/>
+          <p:nvPr/>
+        </p:nvSpPr>
+        <p:spPr>
+          <a:xfrm>
+            <a:off x="685800" y="109728"/>
+            <a:ext cx="10817352" cy="228600"/>
+          </a:xfrm>
+          <a:prstGeom prst="rect">
+            <a:avLst/>
+          </a:prstGeom>
+          <a:noFill/>
+        </p:spPr>
+        <p:txBody>
+          <a:bodyPr wrap="none">
+            <a:spAutoFit/>
+          </a:bodyPr>
+          <a:lstStyle/>
+          <a:p>
+            <a:pPr algn="l"/>
+            <a:r>
+              <a:rPr sz="750">
+                <a:solidFill>
+                  <a:srgbClr val="78808C"/>
+                </a:solidFill>
+                <a:latin typeface="Consolas"/>
+              </a:rPr>
+              <a:t>VA04  ·  INHALT</a:t>
+            </a:r>
+          </a:p>
+        </p:txBody>
+      </p:sp>
+      <p:sp>
+        <p:nvSpPr>
+          <p:cNvPr id="5" name="Rectangle 4"/>
+          <p:cNvSpPr/>
+          <p:nvPr/>
+        </p:nvSpPr>
+        <p:spPr>
+          <a:xfrm>
+            <a:off x="0" y="1234440"/>
+            <a:ext cx="12188952" cy="12700"/>
+          </a:xfrm>
+          <a:prstGeom prst="rect">
+            <a:avLst/>
+          </a:prstGeom>
+          <a:solidFill>
+            <a:srgbClr val="D8DFE4"/>
+          </a:solidFill>
+          <a:ln>
+            <a:noFill/>
+          </a:ln>
+        </p:spPr>
+        <p:style>
+          <a:lnRef idx="1">
+            <a:schemeClr val="accent1"/>
+          </a:lnRef>
+          <a:fillRef idx="3">
+            <a:schemeClr val="accent1"/>
+          </a:fillRef>
+          <a:effectRef idx="2">
+            <a:schemeClr val="accent1"/>
+          </a:effectRef>
+          <a:fontRef idx="minor">
+            <a:schemeClr val="lt1"/>
+          </a:fontRef>
+        </p:style>
+        <p:txBody>
+          <a:bodyPr rtlCol="0" anchor="ctr"/>
+          <a:lstStyle/>
+          <a:p>
+            <a:pPr algn="ctr"/>
+          </a:p>
+        </p:txBody>
+      </p:sp>
+      <p:sp>
+        <p:nvSpPr>
+          <p:cNvPr id="6" name="Rectangle 5"/>
+          <p:cNvSpPr/>
+          <p:nvPr/>
+        </p:nvSpPr>
+        <p:spPr>
+          <a:xfrm>
+            <a:off x="685800" y="502920"/>
+            <a:ext cx="36576" cy="658368"/>
+          </a:xfrm>
+          <a:prstGeom prst="rect">
+            <a:avLst/>
+          </a:prstGeom>
+          <a:solidFill>
+            <a:srgbClr val="D9C089"/>
+          </a:solidFill>
+          <a:ln>
+            <a:noFill/>
+          </a:ln>
+        </p:spPr>
+        <p:style>
+          <a:lnRef idx="1">
+            <a:schemeClr val="accent1"/>
+          </a:lnRef>
+          <a:fillRef idx="3">
+            <a:schemeClr val="accent1"/>
+          </a:fillRef>
+          <a:effectRef idx="2">
+            <a:schemeClr val="accent1"/>
+          </a:effectRef>
+          <a:fontRef idx="minor">
+            <a:schemeClr val="lt1"/>
+          </a:fontRef>
+        </p:style>
+        <p:txBody>
+          <a:bodyPr rtlCol="0" anchor="ctr"/>
+          <a:lstStyle/>
+          <a:p>
+            <a:pPr algn="ctr"/>
+          </a:p>
+        </p:txBody>
+      </p:sp>
+      <p:sp>
+        <p:nvSpPr>
+          <p:cNvPr id="7" name="TextBox 6"/>
+          <p:cNvSpPr txBox="1"/>
+          <p:nvPr/>
+        </p:nvSpPr>
+        <p:spPr>
+          <a:xfrm>
+            <a:off x="813816" y="502920"/>
+            <a:ext cx="10634472" cy="685800"/>
+          </a:xfrm>
+          <a:prstGeom prst="rect">
+            <a:avLst/>
+          </a:prstGeom>
+          <a:noFill/>
+        </p:spPr>
+        <p:txBody>
+          <a:bodyPr wrap="square">
+            <a:spAutoFit/>
+          </a:bodyPr>
+          <a:lstStyle/>
+          <a:p>
+            <a:pPr algn="l"/>
+            <a:r>
+              <a:rPr sz="2400" b="1" i="0">
+                <a:solidFill>
+                  <a:srgbClr val="1F2C56"/>
+                </a:solidFill>
+                <a:latin typeface="Arial"/>
+              </a:rPr>
+              <a:t>Prinzip dieses Moduls</a:t>
+            </a:r>
+          </a:p>
+        </p:txBody>
+      </p:sp>
+      <p:sp>
+        <p:nvSpPr>
+          <p:cNvPr id="8" name="TextBox 7"/>
+          <p:cNvSpPr txBox="1"/>
+          <p:nvPr/>
+        </p:nvSpPr>
+        <p:spPr>
+          <a:xfrm>
+            <a:off x="685800" y="1417320"/>
+            <a:ext cx="10817352" cy="4892040"/>
+          </a:xfrm>
+          <a:prstGeom prst="rect">
+            <a:avLst/>
+          </a:prstGeom>
+          <a:noFill/>
+        </p:spPr>
+        <p:txBody>
+          <a:bodyPr wrap="square" anchor="ctr">
+            <a:spAutoFit/>
+          </a:bodyPr>
+          <a:lstStyle/>
+          <a:p>
+            <a:pPr marL="177800" indent="-177800">
+              <a:spcBef>
+                <a:spcPts val="600"/>
+              </a:spcBef>
+              <a:spcAft>
+                <a:spcPts val="200"/>
+              </a:spcAft>
+            </a:pPr>
+            <a:r>
+              <a:rPr sz="1200" i="1">
+                <a:solidFill>
+                  <a:srgbClr val="3D5466"/>
+                </a:solidFill>
+                <a:latin typeface="Arial"/>
+              </a:rPr>
+              <a:t>→  Eine Frist, die niemand sieht, ist eine Frist, die reißt.</a:t>
+            </a:r>
+          </a:p>
+          <a:p>
+            <a:pPr marL="190500" indent="-190500">
+              <a:spcBef>
+                <a:spcPts val="400"/>
+              </a:spcBef>
+              <a:spcAft>
+                <a:spcPts val="200"/>
+              </a:spcAft>
+            </a:pPr>
+            <a:r>
+              <a:rPr sz="1300">
+                <a:solidFill>
+                  <a:srgbClr val="3D5466"/>
+                </a:solidFill>
+                <a:latin typeface="Arial"/>
+              </a:rPr>
+              <a:t>▸  Ein gepflegtes Wiedervorlage-System und saubere Daten verhindern Schäden, bevor sie entstehen.</a:t>
+            </a:r>
+          </a:p>
+        </p:txBody>
+      </p:sp>
+      <p:sp>
+        <p:nvSpPr>
+          <p:cNvPr id="9" name="Rectangle 8"/>
+          <p:cNvSpPr/>
+          <p:nvPr/>
+        </p:nvSpPr>
+        <p:spPr>
+          <a:xfrm>
+            <a:off x="0" y="6510528"/>
+            <a:ext cx="12188952" cy="347472"/>
+          </a:xfrm>
+          <a:prstGeom prst="rect">
+            <a:avLst/>
+          </a:prstGeom>
+          <a:solidFill>
+            <a:srgbClr val="0A1937"/>
+          </a:solidFill>
+          <a:ln>
+            <a:noFill/>
+          </a:ln>
+        </p:spPr>
+        <p:style>
+          <a:lnRef idx="1">
+            <a:schemeClr val="accent1"/>
+          </a:lnRef>
+          <a:fillRef idx="3">
+            <a:schemeClr val="accent1"/>
+          </a:fillRef>
+          <a:effectRef idx="2">
+            <a:schemeClr val="accent1"/>
+          </a:effectRef>
+          <a:fontRef idx="minor">
+            <a:schemeClr val="lt1"/>
+          </a:fontRef>
+        </p:style>
+        <p:txBody>
+          <a:bodyPr rtlCol="0" anchor="ctr"/>
+          <a:lstStyle/>
+          <a:p>
+            <a:pPr algn="ctr"/>
+          </a:p>
+        </p:txBody>
+      </p:sp>
+      <p:sp>
+        <p:nvSpPr>
+          <p:cNvPr id="10" name="TextBox 9"/>
+          <p:cNvSpPr txBox="1"/>
+          <p:nvPr/>
+        </p:nvSpPr>
+        <p:spPr>
+          <a:xfrm>
+            <a:off x="685800" y="6583680"/>
+            <a:ext cx="6490411" cy="256032"/>
+          </a:xfrm>
+          <a:prstGeom prst="rect">
+            <a:avLst/>
+          </a:prstGeom>
+          <a:noFill/>
+        </p:spPr>
+        <p:txBody>
+          <a:bodyPr wrap="none">
+            <a:spAutoFit/>
+          </a:bodyPr>
+          <a:lstStyle/>
+          <a:p>
+            <a:pPr algn="l"/>
+            <a:r>
+              <a:rPr sz="700">
+                <a:solidFill>
+                  <a:srgbClr val="A0B4D2"/>
+                </a:solidFill>
+                <a:latin typeface="Consolas"/>
+              </a:rPr>
+              <a:t>FKB Campus  ·  VA04</a:t>
+            </a:r>
+          </a:p>
+        </p:txBody>
+      </p:sp>
+    </p:spTree>
+  </p:cSld>
+  <p:clrMapOvr>
+    <a:masterClrMapping/>
+  </p:clrMapOvr>
+</p:sld>
+</file>
+
+<file path=ppt/slides/slide16.xml><?xml version="1.0" encoding="utf-8"?>
+<p:sld xmlns:a="http://schemas.openxmlformats.org/drawingml/2006/main" xmlns:p="http://schemas.openxmlformats.org/presentationml/2006/main" xmlns:r="http://schemas.openxmlformats.org/officeDocument/2006/relationships">
+  <p:cSld>
+    <p:spTree>
+      <p:nvGrpSpPr>
+        <p:cNvPr id="1" name=""/>
+        <p:cNvGrpSpPr/>
+        <p:nvPr/>
+      </p:nvGrpSpPr>
+      <p:grpSpPr/>
+      <p:sp>
+        <p:nvSpPr>
+          <p:cNvPr id="2" name="Rectangle 1"/>
+          <p:cNvSpPr/>
+          <p:nvPr/>
+        </p:nvSpPr>
+        <p:spPr>
+          <a:xfrm>
+            <a:off x="0" y="0"/>
+            <a:ext cx="12188952" cy="6858000"/>
+          </a:xfrm>
+          <a:prstGeom prst="rect">
+            <a:avLst/>
+          </a:prstGeom>
+          <a:solidFill>
+            <a:srgbClr val="EDEDF3"/>
+          </a:solidFill>
+          <a:ln>
+            <a:noFill/>
+          </a:ln>
+        </p:spPr>
+        <p:style>
+          <a:lnRef idx="1">
+            <a:schemeClr val="accent1"/>
+          </a:lnRef>
+          <a:fillRef idx="3">
+            <a:schemeClr val="accent1"/>
+          </a:fillRef>
+          <a:effectRef idx="2">
+            <a:schemeClr val="accent1"/>
+          </a:effectRef>
+          <a:fontRef idx="minor">
+            <a:schemeClr val="lt1"/>
+          </a:fontRef>
+        </p:style>
+        <p:txBody>
+          <a:bodyPr rtlCol="0" anchor="ctr"/>
+          <a:lstStyle/>
+          <a:p>
+            <a:pPr algn="ctr"/>
+          </a:p>
+        </p:txBody>
+      </p:sp>
+      <p:sp>
+        <p:nvSpPr>
+          <p:cNvPr id="3" name="Rectangle 2"/>
+          <p:cNvSpPr/>
+          <p:nvPr/>
+        </p:nvSpPr>
+        <p:spPr>
+          <a:xfrm>
+            <a:off x="0" y="0"/>
+            <a:ext cx="12188952" cy="50292"/>
+          </a:xfrm>
+          <a:prstGeom prst="rect">
+            <a:avLst/>
+          </a:prstGeom>
+          <a:solidFill>
+            <a:srgbClr val="1F2C56"/>
+          </a:solidFill>
+          <a:ln>
+            <a:noFill/>
+          </a:ln>
+        </p:spPr>
+        <p:style>
+          <a:lnRef idx="1">
+            <a:schemeClr val="accent1"/>
+          </a:lnRef>
+          <a:fillRef idx="3">
+            <a:schemeClr val="accent1"/>
+          </a:fillRef>
+          <a:effectRef idx="2">
+            <a:schemeClr val="accent1"/>
+          </a:effectRef>
+          <a:fontRef idx="minor">
+            <a:schemeClr val="lt1"/>
+          </a:fontRef>
+        </p:style>
+        <p:txBody>
+          <a:bodyPr rtlCol="0" anchor="ctr"/>
+          <a:lstStyle/>
+          <a:p>
+            <a:pPr algn="ctr"/>
+          </a:p>
+        </p:txBody>
+      </p:sp>
+      <p:sp>
+        <p:nvSpPr>
+          <p:cNvPr id="4" name="TextBox 3"/>
+          <p:cNvSpPr txBox="1"/>
+          <p:nvPr/>
+        </p:nvSpPr>
+        <p:spPr>
+          <a:xfrm>
+            <a:off x="685800" y="109728"/>
+            <a:ext cx="10817352" cy="228600"/>
+          </a:xfrm>
+          <a:prstGeom prst="rect">
+            <a:avLst/>
+          </a:prstGeom>
+          <a:noFill/>
+        </p:spPr>
+        <p:txBody>
+          <a:bodyPr wrap="none">
+            <a:spAutoFit/>
+          </a:bodyPr>
+          <a:lstStyle/>
+          <a:p>
+            <a:pPr algn="l"/>
+            <a:r>
+              <a:rPr sz="750">
+                <a:solidFill>
+                  <a:srgbClr val="78808C"/>
+                </a:solidFill>
+                <a:latin typeface="Consolas"/>
+              </a:rPr>
+              <a:t>VA04  ·  INHALT</a:t>
+            </a:r>
+          </a:p>
+        </p:txBody>
+      </p:sp>
+      <p:sp>
+        <p:nvSpPr>
+          <p:cNvPr id="5" name="Rectangle 4"/>
+          <p:cNvSpPr/>
+          <p:nvPr/>
+        </p:nvSpPr>
+        <p:spPr>
+          <a:xfrm>
+            <a:off x="0" y="1234440"/>
+            <a:ext cx="12188952" cy="12700"/>
+          </a:xfrm>
+          <a:prstGeom prst="rect">
+            <a:avLst/>
+          </a:prstGeom>
+          <a:solidFill>
+            <a:srgbClr val="D8DFE4"/>
+          </a:solidFill>
+          <a:ln>
+            <a:noFill/>
+          </a:ln>
+        </p:spPr>
+        <p:style>
+          <a:lnRef idx="1">
+            <a:schemeClr val="accent1"/>
+          </a:lnRef>
+          <a:fillRef idx="3">
+            <a:schemeClr val="accent1"/>
+          </a:fillRef>
+          <a:effectRef idx="2">
+            <a:schemeClr val="accent1"/>
+          </a:effectRef>
+          <a:fontRef idx="minor">
+            <a:schemeClr val="lt1"/>
+          </a:fontRef>
+        </p:style>
+        <p:txBody>
+          <a:bodyPr rtlCol="0" anchor="ctr"/>
+          <a:lstStyle/>
+          <a:p>
+            <a:pPr algn="ctr"/>
+          </a:p>
+        </p:txBody>
+      </p:sp>
+      <p:sp>
+        <p:nvSpPr>
+          <p:cNvPr id="6" name="Rectangle 5"/>
+          <p:cNvSpPr/>
+          <p:nvPr/>
+        </p:nvSpPr>
+        <p:spPr>
+          <a:xfrm>
+            <a:off x="685800" y="502920"/>
+            <a:ext cx="36576" cy="658368"/>
+          </a:xfrm>
+          <a:prstGeom prst="rect">
+            <a:avLst/>
+          </a:prstGeom>
+          <a:solidFill>
+            <a:srgbClr val="D9C089"/>
+          </a:solidFill>
+          <a:ln>
+            <a:noFill/>
+          </a:ln>
+        </p:spPr>
+        <p:style>
+          <a:lnRef idx="1">
+            <a:schemeClr val="accent1"/>
+          </a:lnRef>
+          <a:fillRef idx="3">
+            <a:schemeClr val="accent1"/>
+          </a:fillRef>
+          <a:effectRef idx="2">
+            <a:schemeClr val="accent1"/>
+          </a:effectRef>
+          <a:fontRef idx="minor">
+            <a:schemeClr val="lt1"/>
+          </a:fontRef>
+        </p:style>
+        <p:txBody>
+          <a:bodyPr rtlCol="0" anchor="ctr"/>
+          <a:lstStyle/>
+          <a:p>
+            <a:pPr algn="ctr"/>
+          </a:p>
+        </p:txBody>
+      </p:sp>
+      <p:sp>
+        <p:nvSpPr>
+          <p:cNvPr id="7" name="TextBox 6"/>
+          <p:cNvSpPr txBox="1"/>
+          <p:nvPr/>
+        </p:nvSpPr>
+        <p:spPr>
+          <a:xfrm>
+            <a:off x="813816" y="502920"/>
+            <a:ext cx="10634472" cy="685800"/>
+          </a:xfrm>
+          <a:prstGeom prst="rect">
+            <a:avLst/>
+          </a:prstGeom>
+          <a:noFill/>
+        </p:spPr>
+        <p:txBody>
+          <a:bodyPr wrap="square">
+            <a:spAutoFit/>
+          </a:bodyPr>
+          <a:lstStyle/>
+          <a:p>
+            <a:pPr algn="l"/>
+            <a:r>
+              <a:rPr sz="2400" b="1" i="0">
+                <a:solidFill>
+                  <a:srgbClr val="1F2C56"/>
+                </a:solidFill>
+                <a:latin typeface="Arial"/>
+              </a:rPr>
+              <a:t>Reflexionsfragen</a:t>
+            </a:r>
+          </a:p>
+        </p:txBody>
+      </p:sp>
+      <p:sp>
+        <p:nvSpPr>
+          <p:cNvPr id="8" name="TextBox 7"/>
+          <p:cNvSpPr txBox="1"/>
+          <p:nvPr/>
+        </p:nvSpPr>
+        <p:spPr>
+          <a:xfrm>
+            <a:off x="685800" y="1417320"/>
+            <a:ext cx="10817352" cy="4892040"/>
+          </a:xfrm>
+          <a:prstGeom prst="rect">
+            <a:avLst/>
+          </a:prstGeom>
+          <a:noFill/>
+        </p:spPr>
+        <p:txBody>
+          <a:bodyPr wrap="square" anchor="ctr">
+            <a:spAutoFit/>
+          </a:bodyPr>
+          <a:lstStyle/>
+          <a:p>
+            <a:pPr marL="190500" indent="-190500">
+              <a:spcBef>
+                <a:spcPts val="400"/>
+              </a:spcBef>
+              <a:spcAft>
+                <a:spcPts val="200"/>
+              </a:spcAft>
+            </a:pPr>
+            <a:r>
+              <a:rPr sz="1300">
+                <a:solidFill>
+                  <a:srgbClr val="3D5466"/>
+                </a:solidFill>
+                <a:latin typeface="Arial"/>
+              </a:rPr>
+              <a:t>▸  Welche Frist würde Sie am meisten ärgern, wenn sie reißt – und wie sichern Sie genau die ab?</a:t>
+            </a:r>
+          </a:p>
+          <a:p>
+            <a:pPr marL="190500" indent="-190500">
+              <a:spcBef>
+                <a:spcPts val="400"/>
+              </a:spcBef>
+              <a:spcAft>
+                <a:spcPts val="200"/>
+              </a:spcAft>
+            </a:pPr>
+            <a:r>
+              <a:rPr sz="1300">
+                <a:solidFill>
+                  <a:srgbClr val="3D5466"/>
+                </a:solidFill>
+                <a:latin typeface="Arial"/>
+              </a:rPr>
+              <a:t>▸  Welcher auslaufende Vertrag in Ihrem Portfolio ist zugleich ein Vertriebsanlass?</a:t>
+            </a:r>
+          </a:p>
+          <a:p>
+            <a:pPr marL="190500" indent="-190500">
+              <a:spcBef>
+                <a:spcPts val="400"/>
+              </a:spcBef>
+              <a:spcAft>
+                <a:spcPts val="200"/>
+              </a:spcAft>
+            </a:pPr>
+            <a:r>
+              <a:rPr sz="1300">
+                <a:solidFill>
+                  <a:srgbClr val="3D5466"/>
+                </a:solidFill>
+                <a:latin typeface="Arial"/>
+              </a:rPr>
+              <a:t>▸  Bei welcher Datenänderung sind Sie unsicher, ob Sie sie selbst vornehmen dürfen?</a:t>
+            </a:r>
+          </a:p>
+        </p:txBody>
+      </p:sp>
+      <p:sp>
+        <p:nvSpPr>
+          <p:cNvPr id="9" name="Rectangle 8"/>
+          <p:cNvSpPr/>
+          <p:nvPr/>
+        </p:nvSpPr>
+        <p:spPr>
+          <a:xfrm>
+            <a:off x="0" y="6510528"/>
+            <a:ext cx="12188952" cy="347472"/>
+          </a:xfrm>
+          <a:prstGeom prst="rect">
+            <a:avLst/>
+          </a:prstGeom>
+          <a:solidFill>
+            <a:srgbClr val="0A1937"/>
+          </a:solidFill>
+          <a:ln>
+            <a:noFill/>
+          </a:ln>
+        </p:spPr>
+        <p:style>
+          <a:lnRef idx="1">
+            <a:schemeClr val="accent1"/>
+          </a:lnRef>
+          <a:fillRef idx="3">
+            <a:schemeClr val="accent1"/>
+          </a:fillRef>
+          <a:effectRef idx="2">
+            <a:schemeClr val="accent1"/>
+          </a:effectRef>
+          <a:fontRef idx="minor">
+            <a:schemeClr val="lt1"/>
+          </a:fontRef>
+        </p:style>
+        <p:txBody>
+          <a:bodyPr rtlCol="0" anchor="ctr"/>
+          <a:lstStyle/>
+          <a:p>
+            <a:pPr algn="ctr"/>
+          </a:p>
+        </p:txBody>
+      </p:sp>
+      <p:sp>
+        <p:nvSpPr>
+          <p:cNvPr id="10" name="TextBox 9"/>
+          <p:cNvSpPr txBox="1"/>
+          <p:nvPr/>
+        </p:nvSpPr>
+        <p:spPr>
+          <a:xfrm>
+            <a:off x="685800" y="6583680"/>
+            <a:ext cx="6490411" cy="256032"/>
+          </a:xfrm>
+          <a:prstGeom prst="rect">
+            <a:avLst/>
+          </a:prstGeom>
+          <a:noFill/>
+        </p:spPr>
+        <p:txBody>
+          <a:bodyPr wrap="none">
+            <a:spAutoFit/>
+          </a:bodyPr>
+          <a:lstStyle/>
+          <a:p>
+            <a:pPr algn="l"/>
+            <a:r>
+              <a:rPr sz="700">
+                <a:solidFill>
+                  <a:srgbClr val="A0B4D2"/>
+                </a:solidFill>
+                <a:latin typeface="Consolas"/>
+              </a:rPr>
+              <a:t>FKB Campus  ·  VA04</a:t>
+            </a:r>
+          </a:p>
+        </p:txBody>
+      </p:sp>
+    </p:spTree>
+  </p:cSld>
+  <p:clrMapOvr>
+    <a:masterClrMapping/>
+  </p:clrMapOvr>
+</p:sld>
+</file>
+
 <file path=ppt/slides/slide2.xml><?xml version="1.0" encoding="utf-8"?>
 <p:sld xmlns:a="http://schemas.openxmlformats.org/drawingml/2006/main" xmlns:p="http://schemas.openxmlformats.org/presentationml/2006/main" xmlns:r="http://schemas.openxmlformats.org/officeDocument/2006/relationships">
   <p:cSld>
@@ -5774,7 +8917,7 @@
             <a:avLst/>
           </a:prstGeom>
           <a:solidFill>
-            <a:srgbClr val="EDEDF3"/>
+            <a:srgbClr val="1F2C56"/>
           </a:solidFill>
           <a:ln>
             <a:noFill/>
@@ -5804,57 +8947,14 @@
       </p:sp>
       <p:sp>
         <p:nvSpPr>
-          <p:cNvPr id="3" name="Rectangle 2"/>
-          <p:cNvSpPr/>
-          <p:nvPr/>
-        </p:nvSpPr>
-        <p:spPr>
-          <a:xfrm>
-            <a:off x="0" y="0"/>
-            <a:ext cx="12188952" cy="50292"/>
-          </a:xfrm>
-          <a:prstGeom prst="rect">
-            <a:avLst/>
-          </a:prstGeom>
-          <a:solidFill>
-            <a:srgbClr val="1F2C56"/>
-          </a:solidFill>
-          <a:ln>
-            <a:noFill/>
-          </a:ln>
-        </p:spPr>
-        <p:style>
-          <a:lnRef idx="1">
-            <a:schemeClr val="accent1"/>
-          </a:lnRef>
-          <a:fillRef idx="3">
-            <a:schemeClr val="accent1"/>
-          </a:fillRef>
-          <a:effectRef idx="2">
-            <a:schemeClr val="accent1"/>
-          </a:effectRef>
-          <a:fontRef idx="minor">
-            <a:schemeClr val="lt1"/>
-          </a:fontRef>
-        </p:style>
-        <p:txBody>
-          <a:bodyPr rtlCol="0" anchor="ctr"/>
-          <a:lstStyle/>
-          <a:p>
-            <a:pPr algn="ctr"/>
-          </a:p>
-        </p:txBody>
-      </p:sp>
-      <p:sp>
-        <p:nvSpPr>
-          <p:cNvPr id="4" name="TextBox 3"/>
+          <p:cNvPr id="3" name="TextBox 2"/>
           <p:cNvSpPr txBox="1"/>
           <p:nvPr/>
         </p:nvSpPr>
         <p:spPr>
           <a:xfrm>
-            <a:off x="685800" y="109728"/>
-            <a:ext cx="10817352" cy="228600"/>
+            <a:off x="685800" y="2377440"/>
+            <a:ext cx="10817352" cy="365760"/>
           </a:xfrm>
           <a:prstGeom prst="rect">
             <a:avLst/>
@@ -5869,70 +8969,27 @@
           <a:p>
             <a:pPr algn="l"/>
             <a:r>
-              <a:rPr sz="750">
-                <a:solidFill>
-                  <a:srgbClr val="78808C"/>
+              <a:rPr sz="1200">
+                <a:solidFill>
+                  <a:srgbClr val="D9C089"/>
                 </a:solidFill>
                 <a:latin typeface="Consolas"/>
               </a:rPr>
-              <a:t>VA04  ·  INHALT</a:t>
-            </a:r>
-          </a:p>
-        </p:txBody>
-      </p:sp>
-      <p:sp>
-        <p:nvSpPr>
-          <p:cNvPr id="5" name="Rectangle 4"/>
+              <a:t>00:05–00:20</a:t>
+            </a:r>
+          </a:p>
+        </p:txBody>
+      </p:sp>
+      <p:sp>
+        <p:nvSpPr>
+          <p:cNvPr id="4" name="Rectangle 3"/>
           <p:cNvSpPr/>
           <p:nvPr/>
         </p:nvSpPr>
         <p:spPr>
           <a:xfrm>
-            <a:off x="0" y="1234440"/>
-            <a:ext cx="12188952" cy="12700"/>
-          </a:xfrm>
-          <a:prstGeom prst="rect">
-            <a:avLst/>
-          </a:prstGeom>
-          <a:solidFill>
-            <a:srgbClr val="D8DFE4"/>
-          </a:solidFill>
-          <a:ln>
-            <a:noFill/>
-          </a:ln>
-        </p:spPr>
-        <p:style>
-          <a:lnRef idx="1">
-            <a:schemeClr val="accent1"/>
-          </a:lnRef>
-          <a:fillRef idx="3">
-            <a:schemeClr val="accent1"/>
-          </a:fillRef>
-          <a:effectRef idx="2">
-            <a:schemeClr val="accent1"/>
-          </a:effectRef>
-          <a:fontRef idx="minor">
-            <a:schemeClr val="lt1"/>
-          </a:fontRef>
-        </p:style>
-        <p:txBody>
-          <a:bodyPr rtlCol="0" anchor="ctr"/>
-          <a:lstStyle/>
-          <a:p>
-            <a:pPr algn="ctr"/>
-          </a:p>
-        </p:txBody>
-      </p:sp>
-      <p:sp>
-        <p:nvSpPr>
-          <p:cNvPr id="6" name="Rectangle 5"/>
-          <p:cNvSpPr/>
-          <p:nvPr/>
-        </p:nvSpPr>
-        <p:spPr>
-          <a:xfrm>
-            <a:off x="685800" y="502920"/>
-            <a:ext cx="36576" cy="658368"/>
+            <a:off x="685800" y="2788920"/>
+            <a:ext cx="548640" cy="38100"/>
           </a:xfrm>
           <a:prstGeom prst="rect">
             <a:avLst/>
@@ -5968,14 +9025,14 @@
       </p:sp>
       <p:sp>
         <p:nvSpPr>
-          <p:cNvPr id="7" name="TextBox 6"/>
+          <p:cNvPr id="5" name="TextBox 4"/>
           <p:cNvSpPr txBox="1"/>
           <p:nvPr/>
         </p:nvSpPr>
         <p:spPr>
           <a:xfrm>
-            <a:off x="813816" y="502920"/>
-            <a:ext cx="10634472" cy="685800"/>
+            <a:off x="685800" y="3017520"/>
+            <a:ext cx="10817352" cy="1463040"/>
           </a:xfrm>
           <a:prstGeom prst="rect">
             <a:avLst/>
@@ -5990,27 +9047,27 @@
           <a:p>
             <a:pPr algn="l"/>
             <a:r>
-              <a:rPr sz="2400" b="1" i="0">
-                <a:solidFill>
-                  <a:srgbClr val="1F2C56"/>
+              <a:rPr sz="4000" b="1" i="0">
+                <a:solidFill>
+                  <a:srgbClr val="FFFFFF"/>
                 </a:solidFill>
                 <a:latin typeface="Arial"/>
               </a:rPr>
-              <a:t>Theorie-Input: Fristen sind kein Gedächtnissport</a:t>
-            </a:r>
-          </a:p>
-        </p:txBody>
-      </p:sp>
-      <p:sp>
-        <p:nvSpPr>
-          <p:cNvPr id="8" name="TextBox 7"/>
+              <a:t>Theorie-Input 1</a:t>
+            </a:r>
+          </a:p>
+        </p:txBody>
+      </p:sp>
+      <p:sp>
+        <p:nvSpPr>
+          <p:cNvPr id="6" name="TextBox 5"/>
           <p:cNvSpPr txBox="1"/>
           <p:nvPr/>
         </p:nvSpPr>
         <p:spPr>
           <a:xfrm>
-            <a:off x="685800" y="1417320"/>
-            <a:ext cx="10817352" cy="4892040"/>
+            <a:off x="685800" y="4480560"/>
+            <a:ext cx="8653881" cy="1280160"/>
           </a:xfrm>
           <a:prstGeom prst="rect">
             <a:avLst/>
@@ -6018,84 +9075,34 @@
           <a:noFill/>
         </p:spPr>
         <p:txBody>
-          <a:bodyPr wrap="square" anchor="ctr">
+          <a:bodyPr wrap="square">
             <a:spAutoFit/>
           </a:bodyPr>
           <a:lstStyle/>
           <a:p>
-            <a:pPr marL="190500" indent="-190500">
-              <a:spcBef>
-                <a:spcPts val="400"/>
-              </a:spcBef>
-              <a:spcAft>
-                <a:spcPts val="200"/>
-              </a:spcAft>
-            </a:pPr>
-            <a:r>
-              <a:rPr sz="1300">
-                <a:solidFill>
-                  <a:srgbClr val="3D5466"/>
+            <a:pPr algn="l"/>
+            <a:r>
+              <a:rPr sz="1600" b="0" i="0">
+                <a:solidFill>
+                  <a:srgbClr val="C8D2E6"/>
                 </a:solidFill>
                 <a:latin typeface="Arial"/>
               </a:rPr>
-              <a:t>▸  Kritische Fristentypen im Firmenkundengeschäft:</a:t>
-            </a:r>
-          </a:p>
-        </p:txBody>
-      </p:sp>
-      <p:sp>
-        <p:nvSpPr>
-          <p:cNvPr id="9" name="Rectangle 8"/>
-          <p:cNvSpPr/>
-          <p:nvPr/>
-        </p:nvSpPr>
-        <p:spPr>
-          <a:xfrm>
-            <a:off x="0" y="6510528"/>
-            <a:ext cx="12188952" cy="347472"/>
-          </a:xfrm>
-          <a:prstGeom prst="rect">
-            <a:avLst/>
-          </a:prstGeom>
-          <a:solidFill>
-            <a:srgbClr val="0A1937"/>
-          </a:solidFill>
-          <a:ln>
-            <a:noFill/>
-          </a:ln>
-        </p:spPr>
-        <p:style>
-          <a:lnRef idx="1">
-            <a:schemeClr val="accent1"/>
-          </a:lnRef>
-          <a:fillRef idx="3">
-            <a:schemeClr val="accent1"/>
-          </a:fillRef>
-          <a:effectRef idx="2">
-            <a:schemeClr val="accent1"/>
-          </a:effectRef>
-          <a:fontRef idx="minor">
-            <a:schemeClr val="lt1"/>
-          </a:fontRef>
-        </p:style>
-        <p:txBody>
-          <a:bodyPr rtlCol="0" anchor="ctr"/>
-          <a:lstStyle/>
-          <a:p>
-            <a:pPr algn="ctr"/>
-          </a:p>
-        </p:txBody>
-      </p:sp>
-      <p:sp>
-        <p:nvSpPr>
-          <p:cNvPr id="10" name="TextBox 9"/>
+              <a:t>Fristen richtig priorisieren – Risikoart schlägt Zeitnähe.</a:t>
+            </a:r>
+          </a:p>
+        </p:txBody>
+      </p:sp>
+      <p:sp>
+        <p:nvSpPr>
+          <p:cNvPr id="7" name="TextBox 6"/>
           <p:cNvSpPr txBox="1"/>
           <p:nvPr/>
         </p:nvSpPr>
         <p:spPr>
           <a:xfrm>
-            <a:off x="685800" y="6583680"/>
-            <a:ext cx="6490411" cy="256032"/>
+            <a:off x="685800" y="6355080"/>
+            <a:ext cx="10817352" cy="274320"/>
           </a:xfrm>
           <a:prstGeom prst="rect">
             <a:avLst/>
@@ -6112,7 +9119,7 @@
             <a:r>
               <a:rPr sz="700">
                 <a:solidFill>
-                  <a:srgbClr val="A0B4D2"/>
+                  <a:srgbClr val="8CA0C3"/>
                 </a:solidFill>
                 <a:latin typeface="Consolas"/>
               </a:rPr>
@@ -6255,7 +9262,7 @@
                 </a:solidFill>
                 <a:latin typeface="Consolas"/>
               </a:rPr>
-              <a:t>VA04  ·  ARBEITSBLATT</a:t>
+              <a:t>VA04  ·  INHALT</a:t>
             </a:r>
           </a:p>
         </p:txBody>
@@ -6376,7 +9383,7 @@
                 </a:solidFill>
                 <a:latin typeface="Arial"/>
               </a:rPr>
-              <a:t>Praxisfall: Portfolio-Durchsicht</a:t>
+              <a:t>Fristen im Innendienst: Typen und Priorität</a:t>
             </a:r>
           </a:p>
         </p:txBody>
@@ -6389,8 +9396,8 @@
         </p:nvSpPr>
         <p:spPr>
           <a:xfrm>
-            <a:off x="685800" y="1554480"/>
-            <a:ext cx="10817352" cy="3840480"/>
+            <a:off x="685800" y="1417320"/>
+            <a:ext cx="10817352" cy="4892040"/>
           </a:xfrm>
           <a:prstGeom prst="rect">
             <a:avLst/>
@@ -6398,10 +9405,29 @@
           <a:noFill/>
         </p:spPr>
         <p:txBody>
-          <a:bodyPr wrap="square">
+          <a:bodyPr wrap="square" anchor="ctr">
             <a:spAutoFit/>
           </a:bodyPr>
           <a:lstStyle/>
+          <a:p>
+            <a:pPr marL="177800" indent="-177800">
+              <a:spcBef>
+                <a:spcPts val="600"/>
+              </a:spcBef>
+              <a:spcAft>
+                <a:spcPts val="200"/>
+              </a:spcAft>
+            </a:pPr>
+            <a:r>
+              <a:rPr sz="1200" i="1">
+                <a:solidFill>
+                  <a:srgbClr val="3D5466"/>
+                </a:solidFill>
+                <a:latin typeface="Arial"/>
+              </a:rPr>
+              <a:t>→  Alles ins System – mit Frist und Verantwortlichem – und regelmäßig durchgehen. Risikoart schlägt Zeitnähe.</a:t>
+            </a:r>
+          </a:p>
           <a:p>
             <a:pPr marL="190500" indent="-190500">
               <a:spcBef>
@@ -6412,13 +9438,13 @@
               </a:spcAft>
             </a:pPr>
             <a:r>
-              <a:rPr sz="1400">
+              <a:rPr sz="1300">
                 <a:solidFill>
                   <a:srgbClr val="3D5466"/>
                 </a:solidFill>
                 <a:latin typeface="Arial"/>
               </a:rPr>
-              <a:t>▸  Ausgangslage (anonymisiert)</a:t>
+              <a:t>▸  Vier Fristentypen: Offenlegung (§ 18 KWG), Sicherheiten, Vertrag/Konditionen, Auflagen.</a:t>
             </a:r>
           </a:p>
           <a:p>
@@ -6431,13 +9457,13 @@
               </a:spcAft>
             </a:pPr>
             <a:r>
-              <a:rPr sz="1400">
+              <a:rPr sz="1300">
                 <a:solidFill>
                   <a:srgbClr val="3D5466"/>
                 </a:solidFill>
                 <a:latin typeface="Arial"/>
               </a:rPr>
-              <a:t>▸  Sie übernehmen die Innendienst-Betreuung eines Teilportfolios (VR-Bank Musterregion eG). Bei der ersten Durchsicht fällt auf:</a:t>
+              <a:t>▸  Priorität 1 ist immer der § 18-Offenlegungsbefund – regulatorisch kritisch, unabhängig von der Restlaufzeit.</a:t>
             </a:r>
           </a:p>
           <a:p>
@@ -6450,51 +9476,13 @@
               </a:spcAft>
             </a:pPr>
             <a:r>
-              <a:rPr sz="1400">
+              <a:rPr sz="1300">
                 <a:solidFill>
                   <a:srgbClr val="3D5466"/>
                 </a:solidFill>
                 <a:latin typeface="Arial"/>
               </a:rPr>
-              <a:t>▸  Fristen priorisieren</a:t>
-            </a:r>
-          </a:p>
-          <a:p>
-            <a:pPr marL="190500" indent="-190500">
-              <a:spcBef>
-                <a:spcPts val="400"/>
-              </a:spcBef>
-              <a:spcAft>
-                <a:spcPts val="200"/>
-              </a:spcAft>
-            </a:pPr>
-            <a:r>
-              <a:rPr sz="1400">
-                <a:solidFill>
-                  <a:srgbClr val="3D5466"/>
-                </a:solidFill>
-                <a:latin typeface="Arial"/>
-              </a:rPr>
-              <a:t>▸  Anleitung: Bringen Sie die vier Befunde in eine Bearbeitungsreihenfolge und begründen Sie.</a:t>
-            </a:r>
-          </a:p>
-          <a:p>
-            <a:pPr marL="190500" indent="-190500">
-              <a:spcBef>
-                <a:spcPts val="400"/>
-              </a:spcBef>
-              <a:spcAft>
-                <a:spcPts val="200"/>
-              </a:spcAft>
-            </a:pPr>
-            <a:r>
-              <a:rPr sz="1400">
-                <a:solidFill>
-                  <a:srgbClr val="3D5466"/>
-                </a:solidFill>
-                <a:latin typeface="Arial"/>
-              </a:rPr>
-              <a:t>▸  Wiedervorlagen anlegen</a:t>
+              <a:t>▸  Bei Überfälligkeit besteht Meldepflicht an die Marktfolge.</a:t>
             </a:r>
           </a:p>
         </p:txBody>
@@ -6502,84 +9490,6 @@
       <p:sp>
         <p:nvSpPr>
           <p:cNvPr id="9" name="Rectangle 8"/>
-          <p:cNvSpPr/>
-          <p:nvPr/>
-        </p:nvSpPr>
-        <p:spPr>
-          <a:xfrm>
-            <a:off x="685800" y="5486400"/>
-            <a:ext cx="10817352" cy="640080"/>
-          </a:xfrm>
-          <a:prstGeom prst="rect">
-            <a:avLst/>
-          </a:prstGeom>
-          <a:solidFill>
-            <a:srgbClr val="1F2C56"/>
-          </a:solidFill>
-          <a:ln>
-            <a:noFill/>
-          </a:ln>
-        </p:spPr>
-        <p:style>
-          <a:lnRef idx="1">
-            <a:schemeClr val="accent1"/>
-          </a:lnRef>
-          <a:fillRef idx="3">
-            <a:schemeClr val="accent1"/>
-          </a:fillRef>
-          <a:effectRef idx="2">
-            <a:schemeClr val="accent1"/>
-          </a:effectRef>
-          <a:fontRef idx="minor">
-            <a:schemeClr val="lt1"/>
-          </a:fontRef>
-        </p:style>
-        <p:txBody>
-          <a:bodyPr rtlCol="0" anchor="ctr"/>
-          <a:lstStyle/>
-          <a:p>
-            <a:pPr algn="ctr"/>
-          </a:p>
-        </p:txBody>
-      </p:sp>
-      <p:sp>
-        <p:nvSpPr>
-          <p:cNvPr id="10" name="TextBox 9"/>
-          <p:cNvSpPr txBox="1"/>
-          <p:nvPr/>
-        </p:nvSpPr>
-        <p:spPr>
-          <a:xfrm>
-            <a:off x="868680" y="5596128"/>
-            <a:ext cx="10451592" cy="457200"/>
-          </a:xfrm>
-          <a:prstGeom prst="rect">
-            <a:avLst/>
-          </a:prstGeom>
-          <a:noFill/>
-        </p:spPr>
-        <p:txBody>
-          <a:bodyPr wrap="square">
-            <a:spAutoFit/>
-          </a:bodyPr>
-          <a:lstStyle/>
-          <a:p>
-            <a:pPr algn="l"/>
-            <a:r>
-              <a:rPr sz="1300" b="1" i="0">
-                <a:solidFill>
-                  <a:srgbClr val="FFFFFF"/>
-                </a:solidFill>
-                <a:latin typeface="Arial"/>
-              </a:rPr>
-              <a:t>→  Bearbeitung im Teilnehmer-Workbook (Arbeitsblatt mit Ausfüllfeldern)</a:t>
-            </a:r>
-          </a:p>
-        </p:txBody>
-      </p:sp>
-      <p:sp>
-        <p:nvSpPr>
-          <p:cNvPr id="11" name="Rectangle 10"/>
           <p:cNvSpPr/>
           <p:nvPr/>
         </p:nvSpPr>
@@ -6622,7 +9532,7 @@
       </p:sp>
       <p:sp>
         <p:nvSpPr>
-          <p:cNvPr id="12" name="TextBox 11"/>
+          <p:cNvPr id="10" name="TextBox 9"/>
           <p:cNvSpPr txBox="1"/>
           <p:nvPr/>
         </p:nvSpPr>
@@ -6688,7 +9598,7 @@
             <a:avLst/>
           </a:prstGeom>
           <a:solidFill>
-            <a:srgbClr val="EDEDF3"/>
+            <a:srgbClr val="FFFFFF"/>
           </a:solidFill>
           <a:ln>
             <a:noFill/>
@@ -6789,6 +9699,604 @@
                 </a:solidFill>
                 <a:latin typeface="Consolas"/>
               </a:rPr>
+              <a:t>VA04  ·  SCHAUBILD</a:t>
+            </a:r>
+          </a:p>
+        </p:txBody>
+      </p:sp>
+      <p:sp>
+        <p:nvSpPr>
+          <p:cNvPr id="5" name="TextBox 4"/>
+          <p:cNvSpPr txBox="1"/>
+          <p:nvPr/>
+        </p:nvSpPr>
+        <p:spPr>
+          <a:xfrm>
+            <a:off x="685800" y="502920"/>
+            <a:ext cx="10817352" cy="594360"/>
+          </a:xfrm>
+          <a:prstGeom prst="rect">
+            <a:avLst/>
+          </a:prstGeom>
+          <a:noFill/>
+        </p:spPr>
+        <p:txBody>
+          <a:bodyPr wrap="square">
+            <a:spAutoFit/>
+          </a:bodyPr>
+          <a:lstStyle/>
+          <a:p>
+            <a:pPr algn="l"/>
+            <a:r>
+              <a:rPr sz="2000" b="1" i="0">
+                <a:solidFill>
+                  <a:srgbClr val="1F2C56"/>
+                </a:solidFill>
+                <a:latin typeface="Arial"/>
+              </a:rPr>
+              <a:t>Fristen priorisieren: Risikoart schlägt Zeitnähe</a:t>
+            </a:r>
+          </a:p>
+        </p:txBody>
+      </p:sp>
+      <p:sp>
+        <p:nvSpPr>
+          <p:cNvPr id="6" name="Rectangle 5"/>
+          <p:cNvSpPr/>
+          <p:nvPr/>
+        </p:nvSpPr>
+        <p:spPr>
+          <a:xfrm>
+            <a:off x="685800" y="1143000"/>
+            <a:ext cx="10817352" cy="25400"/>
+          </a:xfrm>
+          <a:prstGeom prst="rect">
+            <a:avLst/>
+          </a:prstGeom>
+          <a:solidFill>
+            <a:srgbClr val="D9C089"/>
+          </a:solidFill>
+          <a:ln>
+            <a:noFill/>
+          </a:ln>
+        </p:spPr>
+        <p:style>
+          <a:lnRef idx="1">
+            <a:schemeClr val="accent1"/>
+          </a:lnRef>
+          <a:fillRef idx="3">
+            <a:schemeClr val="accent1"/>
+          </a:fillRef>
+          <a:effectRef idx="2">
+            <a:schemeClr val="accent1"/>
+          </a:effectRef>
+          <a:fontRef idx="minor">
+            <a:schemeClr val="lt1"/>
+          </a:fontRef>
+        </p:style>
+        <p:txBody>
+          <a:bodyPr rtlCol="0" anchor="ctr"/>
+          <a:lstStyle/>
+          <a:p>
+            <a:pPr algn="ctr"/>
+          </a:p>
+        </p:txBody>
+      </p:sp>
+      <p:pic>
+        <p:nvPicPr>
+          <p:cNvPr id="7" name="Picture 6" descr="image.png"/>
+          <p:cNvPicPr>
+            <a:picLocks noChangeAspect="1"/>
+          </p:cNvPicPr>
+          <p:nvPr/>
+        </p:nvPicPr>
+        <p:blipFill>
+          <a:blip r:embed="rId2"/>
+          <a:stretch>
+            <a:fillRect/>
+          </a:stretch>
+        </p:blipFill>
+        <p:spPr>
+          <a:xfrm>
+            <a:off x="2009463" y="1325880"/>
+            <a:ext cx="8170026" cy="4937760"/>
+          </a:xfrm>
+          <a:prstGeom prst="rect">
+            <a:avLst/>
+          </a:prstGeom>
+        </p:spPr>
+      </p:pic>
+      <p:sp>
+        <p:nvSpPr>
+          <p:cNvPr id="8" name="Rectangle 7"/>
+          <p:cNvSpPr/>
+          <p:nvPr/>
+        </p:nvSpPr>
+        <p:spPr>
+          <a:xfrm>
+            <a:off x="0" y="6510528"/>
+            <a:ext cx="12188952" cy="347472"/>
+          </a:xfrm>
+          <a:prstGeom prst="rect">
+            <a:avLst/>
+          </a:prstGeom>
+          <a:solidFill>
+            <a:srgbClr val="0A1937"/>
+          </a:solidFill>
+          <a:ln>
+            <a:noFill/>
+          </a:ln>
+        </p:spPr>
+        <p:style>
+          <a:lnRef idx="1">
+            <a:schemeClr val="accent1"/>
+          </a:lnRef>
+          <a:fillRef idx="3">
+            <a:schemeClr val="accent1"/>
+          </a:fillRef>
+          <a:effectRef idx="2">
+            <a:schemeClr val="accent1"/>
+          </a:effectRef>
+          <a:fontRef idx="minor">
+            <a:schemeClr val="lt1"/>
+          </a:fontRef>
+        </p:style>
+        <p:txBody>
+          <a:bodyPr rtlCol="0" anchor="ctr"/>
+          <a:lstStyle/>
+          <a:p>
+            <a:pPr algn="ctr"/>
+          </a:p>
+        </p:txBody>
+      </p:sp>
+      <p:sp>
+        <p:nvSpPr>
+          <p:cNvPr id="9" name="TextBox 8"/>
+          <p:cNvSpPr txBox="1"/>
+          <p:nvPr/>
+        </p:nvSpPr>
+        <p:spPr>
+          <a:xfrm>
+            <a:off x="685800" y="6583680"/>
+            <a:ext cx="6490411" cy="256032"/>
+          </a:xfrm>
+          <a:prstGeom prst="rect">
+            <a:avLst/>
+          </a:prstGeom>
+          <a:noFill/>
+        </p:spPr>
+        <p:txBody>
+          <a:bodyPr wrap="none">
+            <a:spAutoFit/>
+          </a:bodyPr>
+          <a:lstStyle/>
+          <a:p>
+            <a:pPr algn="l"/>
+            <a:r>
+              <a:rPr sz="700">
+                <a:solidFill>
+                  <a:srgbClr val="A0B4D2"/>
+                </a:solidFill>
+                <a:latin typeface="Consolas"/>
+              </a:rPr>
+              <a:t>FKB Campus  ·  VA04</a:t>
+            </a:r>
+          </a:p>
+        </p:txBody>
+      </p:sp>
+      <p:sp>
+        <p:nvSpPr>
+          <p:cNvPr id="10" name="TextBox 9"/>
+          <p:cNvSpPr txBox="1"/>
+          <p:nvPr/>
+        </p:nvSpPr>
+        <p:spPr>
+          <a:xfrm>
+            <a:off x="7176211" y="6583680"/>
+            <a:ext cx="4326940" cy="256032"/>
+          </a:xfrm>
+          <a:prstGeom prst="rect">
+            <a:avLst/>
+          </a:prstGeom>
+          <a:noFill/>
+        </p:spPr>
+        <p:txBody>
+          <a:bodyPr wrap="none">
+            <a:spAutoFit/>
+          </a:bodyPr>
+          <a:lstStyle/>
+          <a:p>
+            <a:pPr algn="r"/>
+            <a:r>
+              <a:rPr sz="700">
+                <a:solidFill>
+                  <a:srgbClr val="A0B4D2"/>
+                </a:solidFill>
+                <a:latin typeface="Consolas"/>
+              </a:rPr>
+              <a:t>Schaubild</a:t>
+            </a:r>
+          </a:p>
+        </p:txBody>
+      </p:sp>
+    </p:spTree>
+  </p:cSld>
+  <p:clrMapOvr>
+    <a:masterClrMapping/>
+  </p:clrMapOvr>
+</p:sld>
+</file>
+
+<file path=ppt/slides/slide8.xml><?xml version="1.0" encoding="utf-8"?>
+<p:sld xmlns:a="http://schemas.openxmlformats.org/drawingml/2006/main" xmlns:p="http://schemas.openxmlformats.org/presentationml/2006/main" xmlns:r="http://schemas.openxmlformats.org/officeDocument/2006/relationships">
+  <p:cSld>
+    <p:spTree>
+      <p:nvGrpSpPr>
+        <p:cNvPr id="1" name=""/>
+        <p:cNvGrpSpPr/>
+        <p:nvPr/>
+      </p:nvGrpSpPr>
+      <p:grpSpPr/>
+      <p:sp>
+        <p:nvSpPr>
+          <p:cNvPr id="2" name="Rectangle 1"/>
+          <p:cNvSpPr/>
+          <p:nvPr/>
+        </p:nvSpPr>
+        <p:spPr>
+          <a:xfrm>
+            <a:off x="0" y="0"/>
+            <a:ext cx="12188952" cy="6858000"/>
+          </a:xfrm>
+          <a:prstGeom prst="rect">
+            <a:avLst/>
+          </a:prstGeom>
+          <a:solidFill>
+            <a:srgbClr val="1F2C56"/>
+          </a:solidFill>
+          <a:ln>
+            <a:noFill/>
+          </a:ln>
+        </p:spPr>
+        <p:style>
+          <a:lnRef idx="1">
+            <a:schemeClr val="accent1"/>
+          </a:lnRef>
+          <a:fillRef idx="3">
+            <a:schemeClr val="accent1"/>
+          </a:fillRef>
+          <a:effectRef idx="2">
+            <a:schemeClr val="accent1"/>
+          </a:effectRef>
+          <a:fontRef idx="minor">
+            <a:schemeClr val="lt1"/>
+          </a:fontRef>
+        </p:style>
+        <p:txBody>
+          <a:bodyPr rtlCol="0" anchor="ctr"/>
+          <a:lstStyle/>
+          <a:p>
+            <a:pPr algn="ctr"/>
+          </a:p>
+        </p:txBody>
+      </p:sp>
+      <p:sp>
+        <p:nvSpPr>
+          <p:cNvPr id="3" name="TextBox 2"/>
+          <p:cNvSpPr txBox="1"/>
+          <p:nvPr/>
+        </p:nvSpPr>
+        <p:spPr>
+          <a:xfrm>
+            <a:off x="685800" y="2377440"/>
+            <a:ext cx="10817352" cy="365760"/>
+          </a:xfrm>
+          <a:prstGeom prst="rect">
+            <a:avLst/>
+          </a:prstGeom>
+          <a:noFill/>
+        </p:spPr>
+        <p:txBody>
+          <a:bodyPr wrap="none">
+            <a:spAutoFit/>
+          </a:bodyPr>
+          <a:lstStyle/>
+          <a:p>
+            <a:pPr algn="l"/>
+            <a:r>
+              <a:rPr sz="1200">
+                <a:solidFill>
+                  <a:srgbClr val="D9C089"/>
+                </a:solidFill>
+                <a:latin typeface="Consolas"/>
+              </a:rPr>
+              <a:t>00:20–00:30</a:t>
+            </a:r>
+          </a:p>
+        </p:txBody>
+      </p:sp>
+      <p:sp>
+        <p:nvSpPr>
+          <p:cNvPr id="4" name="Rectangle 3"/>
+          <p:cNvSpPr/>
+          <p:nvPr/>
+        </p:nvSpPr>
+        <p:spPr>
+          <a:xfrm>
+            <a:off x="685800" y="2788920"/>
+            <a:ext cx="548640" cy="38100"/>
+          </a:xfrm>
+          <a:prstGeom prst="rect">
+            <a:avLst/>
+          </a:prstGeom>
+          <a:solidFill>
+            <a:srgbClr val="D9C089"/>
+          </a:solidFill>
+          <a:ln>
+            <a:noFill/>
+          </a:ln>
+        </p:spPr>
+        <p:style>
+          <a:lnRef idx="1">
+            <a:schemeClr val="accent1"/>
+          </a:lnRef>
+          <a:fillRef idx="3">
+            <a:schemeClr val="accent1"/>
+          </a:fillRef>
+          <a:effectRef idx="2">
+            <a:schemeClr val="accent1"/>
+          </a:effectRef>
+          <a:fontRef idx="minor">
+            <a:schemeClr val="lt1"/>
+          </a:fontRef>
+        </p:style>
+        <p:txBody>
+          <a:bodyPr rtlCol="0" anchor="ctr"/>
+          <a:lstStyle/>
+          <a:p>
+            <a:pPr algn="ctr"/>
+          </a:p>
+        </p:txBody>
+      </p:sp>
+      <p:sp>
+        <p:nvSpPr>
+          <p:cNvPr id="5" name="TextBox 4"/>
+          <p:cNvSpPr txBox="1"/>
+          <p:nvPr/>
+        </p:nvSpPr>
+        <p:spPr>
+          <a:xfrm>
+            <a:off x="685800" y="3017520"/>
+            <a:ext cx="10817352" cy="1463040"/>
+          </a:xfrm>
+          <a:prstGeom prst="rect">
+            <a:avLst/>
+          </a:prstGeom>
+          <a:noFill/>
+        </p:spPr>
+        <p:txBody>
+          <a:bodyPr wrap="square">
+            <a:spAutoFit/>
+          </a:bodyPr>
+          <a:lstStyle/>
+          <a:p>
+            <a:pPr algn="l"/>
+            <a:r>
+              <a:rPr sz="4000" b="1" i="0">
+                <a:solidFill>
+                  <a:srgbClr val="FFFFFF"/>
+                </a:solidFill>
+                <a:latin typeface="Arial"/>
+              </a:rPr>
+              <a:t>Theorie-Input 2</a:t>
+            </a:r>
+          </a:p>
+        </p:txBody>
+      </p:sp>
+      <p:sp>
+        <p:nvSpPr>
+          <p:cNvPr id="6" name="TextBox 5"/>
+          <p:cNvSpPr txBox="1"/>
+          <p:nvPr/>
+        </p:nvSpPr>
+        <p:spPr>
+          <a:xfrm>
+            <a:off x="685800" y="4480560"/>
+            <a:ext cx="8653881" cy="1280160"/>
+          </a:xfrm>
+          <a:prstGeom prst="rect">
+            <a:avLst/>
+          </a:prstGeom>
+          <a:noFill/>
+        </p:spPr>
+        <p:txBody>
+          <a:bodyPr wrap="square">
+            <a:spAutoFit/>
+          </a:bodyPr>
+          <a:lstStyle/>
+          <a:p>
+            <a:pPr algn="l"/>
+            <a:r>
+              <a:rPr sz="1600" b="0" i="0">
+                <a:solidFill>
+                  <a:srgbClr val="C8D2E6"/>
+                </a:solidFill>
+                <a:latin typeface="Arial"/>
+              </a:rPr>
+              <a:t>Datenqualität sichern – und die eigene Berechtigungstiefe kennen.</a:t>
+            </a:r>
+          </a:p>
+        </p:txBody>
+      </p:sp>
+      <p:sp>
+        <p:nvSpPr>
+          <p:cNvPr id="7" name="TextBox 6"/>
+          <p:cNvSpPr txBox="1"/>
+          <p:nvPr/>
+        </p:nvSpPr>
+        <p:spPr>
+          <a:xfrm>
+            <a:off x="685800" y="6355080"/>
+            <a:ext cx="10817352" cy="274320"/>
+          </a:xfrm>
+          <a:prstGeom prst="rect">
+            <a:avLst/>
+          </a:prstGeom>
+          <a:noFill/>
+        </p:spPr>
+        <p:txBody>
+          <a:bodyPr wrap="none">
+            <a:spAutoFit/>
+          </a:bodyPr>
+          <a:lstStyle/>
+          <a:p>
+            <a:pPr algn="l"/>
+            <a:r>
+              <a:rPr sz="700">
+                <a:solidFill>
+                  <a:srgbClr val="8CA0C3"/>
+                </a:solidFill>
+                <a:latin typeface="Consolas"/>
+              </a:rPr>
+              <a:t>FKB Campus  ·  VA04</a:t>
+            </a:r>
+          </a:p>
+        </p:txBody>
+      </p:sp>
+    </p:spTree>
+  </p:cSld>
+  <p:clrMapOvr>
+    <a:masterClrMapping/>
+  </p:clrMapOvr>
+</p:sld>
+</file>
+
+<file path=ppt/slides/slide9.xml><?xml version="1.0" encoding="utf-8"?>
+<p:sld xmlns:a="http://schemas.openxmlformats.org/drawingml/2006/main" xmlns:p="http://schemas.openxmlformats.org/presentationml/2006/main" xmlns:r="http://schemas.openxmlformats.org/officeDocument/2006/relationships">
+  <p:cSld>
+    <p:spTree>
+      <p:nvGrpSpPr>
+        <p:cNvPr id="1" name=""/>
+        <p:cNvGrpSpPr/>
+        <p:nvPr/>
+      </p:nvGrpSpPr>
+      <p:grpSpPr/>
+      <p:sp>
+        <p:nvSpPr>
+          <p:cNvPr id="2" name="Rectangle 1"/>
+          <p:cNvSpPr/>
+          <p:nvPr/>
+        </p:nvSpPr>
+        <p:spPr>
+          <a:xfrm>
+            <a:off x="0" y="0"/>
+            <a:ext cx="12188952" cy="6858000"/>
+          </a:xfrm>
+          <a:prstGeom prst="rect">
+            <a:avLst/>
+          </a:prstGeom>
+          <a:solidFill>
+            <a:srgbClr val="EDEDF3"/>
+          </a:solidFill>
+          <a:ln>
+            <a:noFill/>
+          </a:ln>
+        </p:spPr>
+        <p:style>
+          <a:lnRef idx="1">
+            <a:schemeClr val="accent1"/>
+          </a:lnRef>
+          <a:fillRef idx="3">
+            <a:schemeClr val="accent1"/>
+          </a:fillRef>
+          <a:effectRef idx="2">
+            <a:schemeClr val="accent1"/>
+          </a:effectRef>
+          <a:fontRef idx="minor">
+            <a:schemeClr val="lt1"/>
+          </a:fontRef>
+        </p:style>
+        <p:txBody>
+          <a:bodyPr rtlCol="0" anchor="ctr"/>
+          <a:lstStyle/>
+          <a:p>
+            <a:pPr algn="ctr"/>
+          </a:p>
+        </p:txBody>
+      </p:sp>
+      <p:sp>
+        <p:nvSpPr>
+          <p:cNvPr id="3" name="Rectangle 2"/>
+          <p:cNvSpPr/>
+          <p:nvPr/>
+        </p:nvSpPr>
+        <p:spPr>
+          <a:xfrm>
+            <a:off x="0" y="0"/>
+            <a:ext cx="12188952" cy="50292"/>
+          </a:xfrm>
+          <a:prstGeom prst="rect">
+            <a:avLst/>
+          </a:prstGeom>
+          <a:solidFill>
+            <a:srgbClr val="1F2C56"/>
+          </a:solidFill>
+          <a:ln>
+            <a:noFill/>
+          </a:ln>
+        </p:spPr>
+        <p:style>
+          <a:lnRef idx="1">
+            <a:schemeClr val="accent1"/>
+          </a:lnRef>
+          <a:fillRef idx="3">
+            <a:schemeClr val="accent1"/>
+          </a:fillRef>
+          <a:effectRef idx="2">
+            <a:schemeClr val="accent1"/>
+          </a:effectRef>
+          <a:fontRef idx="minor">
+            <a:schemeClr val="lt1"/>
+          </a:fontRef>
+        </p:style>
+        <p:txBody>
+          <a:bodyPr rtlCol="0" anchor="ctr"/>
+          <a:lstStyle/>
+          <a:p>
+            <a:pPr algn="ctr"/>
+          </a:p>
+        </p:txBody>
+      </p:sp>
+      <p:sp>
+        <p:nvSpPr>
+          <p:cNvPr id="4" name="TextBox 3"/>
+          <p:cNvSpPr txBox="1"/>
+          <p:nvPr/>
+        </p:nvSpPr>
+        <p:spPr>
+          <a:xfrm>
+            <a:off x="685800" y="109728"/>
+            <a:ext cx="10817352" cy="228600"/>
+          </a:xfrm>
+          <a:prstGeom prst="rect">
+            <a:avLst/>
+          </a:prstGeom>
+          <a:noFill/>
+        </p:spPr>
+        <p:txBody>
+          <a:bodyPr wrap="none">
+            <a:spAutoFit/>
+          </a:bodyPr>
+          <a:lstStyle/>
+          <a:p>
+            <a:pPr algn="l"/>
+            <a:r>
+              <a:rPr sz="750">
+                <a:solidFill>
+                  <a:srgbClr val="78808C"/>
+                </a:solidFill>
+                <a:latin typeface="Consolas"/>
+              </a:rPr>
               <a:t>VA04  ·  INHALT</a:t>
             </a:r>
           </a:p>
@@ -6910,7 +10418,7 @@
                 </a:solidFill>
                 <a:latin typeface="Arial"/>
               </a:rPr>
-              <a:t>Reflexionsfragen</a:t>
+              <a:t>Datenqualität und Berechtigungstiefe</a:t>
             </a:r>
           </a:p>
         </p:txBody>
@@ -6932,10 +10440,48 @@
           <a:noFill/>
         </p:spPr>
         <p:txBody>
-          <a:bodyPr wrap="square" anchor="ctr">
+          <a:bodyPr wrap="square">
             <a:spAutoFit/>
           </a:bodyPr>
           <a:lstStyle/>
+          <a:p>
+            <a:pPr marL="177800" indent="-177800">
+              <a:spcBef>
+                <a:spcPts val="600"/>
+              </a:spcBef>
+              <a:spcAft>
+                <a:spcPts val="200"/>
+              </a:spcAft>
+            </a:pPr>
+            <a:r>
+              <a:rPr sz="1200" i="1">
+                <a:solidFill>
+                  <a:srgbClr val="3D5466"/>
+                </a:solidFill>
+                <a:latin typeface="Arial"/>
+              </a:rPr>
+              <a:t>→  Aus schlechten Daten entstehen schlechte Entscheidungen – saubere Stammdaten sind die Rohstoffbasis für die Vertriebsarbeit (Brücke zu VA09).</a:t>
+            </a:r>
+          </a:p>
+          <a:p>
+            <a:pPr>
+              <a:spcBef>
+                <a:spcPts val="1000"/>
+              </a:spcBef>
+              <a:spcAft>
+                <a:spcPts val="200"/>
+              </a:spcAft>
+            </a:pPr>
+            <a:r>
+              <a:rPr sz="800" b="1">
+                <a:solidFill>
+                  <a:srgbClr val="78808C"/>
+                </a:solidFill>
+                <a:latin typeface="Consolas"/>
+              </a:rPr>
+              <a:t>TYPISCHE MÄNGELBILDER</a:t>
+            </a:r>
+          </a:p>
           <a:p>
             <a:pPr marL="190500" indent="-190500">
               <a:spcBef>
@@ -6952,7 +10498,26 @@
                 </a:solidFill>
                 <a:latin typeface="Arial"/>
               </a:rPr>
-              <a:t>▸  Welche Frist würde Sie am meisten ärgern, wenn sie übersehen würde – und ist sie heute im System?</a:t>
+              <a:t>▸  Postrückläufer, veralteter Ansprechpartner, falscher Branchenschlüssel.</a:t>
+            </a:r>
+          </a:p>
+          <a:p>
+            <a:pPr>
+              <a:spcBef>
+                <a:spcPts val="1000"/>
+              </a:spcBef>
+              <a:spcAft>
+                <a:spcPts val="200"/>
+              </a:spcAft>
+            </a:pPr>
+            <a:r>
+              <a:rPr sz="800" b="1">
+                <a:solidFill>
+                  <a:srgbClr val="78808C"/>
+                </a:solidFill>
+                <a:latin typeface="Consolas"/>
+              </a:rPr>
+              <a:t>WAS DARF ICH SELBST ÄNDERN?</a:t>
             </a:r>
           </a:p>
           <a:p>
@@ -6971,7 +10536,7 @@
                 </a:solidFill>
                 <a:latin typeface="Arial"/>
               </a:rPr>
-              <a:t>▸  Wo in Ihrem Bestand vermuten Sie die größten Datenqualitätslücken?</a:t>
+              <a:t>▸  Meist erlaubt: Adresse, Ansprechpartner, Telefon, interne Vermerke.</a:t>
             </a:r>
           </a:p>
           <a:p>
@@ -6990,7 +10555,7 @@
                 </a:solidFill>
                 <a:latin typeface="Arial"/>
               </a:rPr>
-              <a:t>▸  Welcher auslaufende Vertrag ist eigentlich ein Vertriebsanlass?</a:t>
+              <a:t>▸  Immer Freigabe: Rating-Merkmale, Risikoklasse, Kreditnehmereinheit, Grundpfandrechtswerte.</a:t>
             </a:r>
           </a:p>
         </p:txBody>

</xml_diff>